<commit_message>
docs(pitch): apply Trexure brand logo to pitch-deck-v3.pptx
Replace the placeholder pentagon mark with the real Trexure logo
(public/logo.png — shield + converging streams + gold keyhole):
- full logo lockup on the cover and closing slides
- small brand mark, top-right, on every content slide
Palette/type were already on-brand; this adds the actual logo asset.

Co-Authored-By: Claude Opus 4.8 <noreply@anthropic.com>
Claude-Session: https://claude.ai/code/session_01EiquWdpoHJaLq9xBqbbKr9
</commit_message>
<xml_diff>
--- a/docs/pitch-deck-v3.pptx
+++ b/docs/pitch-deck-v3.pptx
@@ -4306,50 +4306,30 @@
           </a:p>
         </p:txBody>
       </p:sp>
-      <p:sp>
-        <p:nvSpPr>
-          <p:cNvPr id="4" name="Pentagon 3"/>
-          <p:cNvSpPr/>
-          <p:nvPr/>
-        </p:nvSpPr>
-        <p:spPr>
-          <a:xfrm>
-            <a:off x="822960" y="2103120"/>
-            <a:ext cx="822960" cy="822960"/>
-          </a:xfrm>
-          <a:prstGeom prst="homePlate">
-            <a:avLst/>
-          </a:prstGeom>
-          <a:solidFill>
-            <a:srgbClr val="8E44AD"/>
-          </a:solidFill>
-          <a:ln>
-            <a:noFill/>
-          </a:ln>
-          <a:effectLst/>
-        </p:spPr>
-        <p:style>
-          <a:lnRef idx="1">
-            <a:schemeClr val="accent1"/>
-          </a:lnRef>
-          <a:fillRef idx="3">
-            <a:schemeClr val="accent1"/>
-          </a:fillRef>
-          <a:effectRef idx="2">
-            <a:schemeClr val="accent1"/>
-          </a:effectRef>
-          <a:fontRef idx="minor">
-            <a:schemeClr val="lt1"/>
-          </a:fontRef>
-        </p:style>
-        <p:txBody>
-          <a:bodyPr rtlCol="0" anchor="ctr"/>
-          <a:lstStyle/>
-          <a:p>
-            <a:pPr algn="ctr"/>
-          </a:p>
-        </p:txBody>
-      </p:sp>
+      <p:pic>
+        <p:nvPicPr>
+          <p:cNvPr id="4" name="Picture 3" descr="logo_trim.png"/>
+          <p:cNvPicPr>
+            <a:picLocks noChangeAspect="1"/>
+          </p:cNvPicPr>
+          <p:nvPr/>
+        </p:nvPicPr>
+        <p:blipFill>
+          <a:blip r:embed="rId2"/>
+          <a:stretch>
+            <a:fillRect/>
+          </a:stretch>
+        </p:blipFill>
+        <p:spPr>
+          <a:xfrm>
+            <a:off x="822960" y="1965960"/>
+            <a:ext cx="806364" cy="960120"/>
+          </a:xfrm>
+          <a:prstGeom prst="rect">
+            <a:avLst/>
+          </a:prstGeom>
+        </p:spPr>
+      </p:pic>
       <p:sp>
         <p:nvSpPr>
           <p:cNvPr id="5" name="TextBox 4"/>
@@ -5654,9 +5634,33 @@
           </a:p>
         </p:txBody>
       </p:sp>
-      <p:sp>
-        <p:nvSpPr>
-          <p:cNvPr id="21" name="TextBox 20"/>
+      <p:pic>
+        <p:nvPicPr>
+          <p:cNvPr id="21" name="Picture 20" descr="logo_trim.png"/>
+          <p:cNvPicPr>
+            <a:picLocks noChangeAspect="1"/>
+          </p:cNvPicPr>
+          <p:nvPr/>
+        </p:nvPicPr>
+        <p:blipFill>
+          <a:blip r:embed="rId2"/>
+          <a:stretch>
+            <a:fillRect/>
+          </a:stretch>
+        </p:blipFill>
+        <p:spPr>
+          <a:xfrm>
+            <a:off x="11539728" y="457200"/>
+            <a:ext cx="307186" cy="365760"/>
+          </a:xfrm>
+          <a:prstGeom prst="rect">
+            <a:avLst/>
+          </a:prstGeom>
+        </p:spPr>
+      </p:pic>
+      <p:sp>
+        <p:nvSpPr>
+          <p:cNvPr id="22" name="TextBox 21"/>
           <p:cNvSpPr txBox="1"/>
           <p:nvPr/>
         </p:nvSpPr>
@@ -5701,7 +5705,7 @@
       </p:sp>
       <p:sp>
         <p:nvSpPr>
-          <p:cNvPr id="22" name="TextBox 21"/>
+          <p:cNvPr id="23" name="TextBox 22"/>
           <p:cNvSpPr txBox="1"/>
           <p:nvPr/>
         </p:nvSpPr>
@@ -5850,50 +5854,30 @@
           </a:p>
         </p:txBody>
       </p:sp>
-      <p:sp>
-        <p:nvSpPr>
-          <p:cNvPr id="4" name="Pentagon 3"/>
-          <p:cNvSpPr/>
-          <p:nvPr/>
-        </p:nvSpPr>
-        <p:spPr>
-          <a:xfrm>
-            <a:off x="822960" y="1371600"/>
-            <a:ext cx="640080" cy="640080"/>
-          </a:xfrm>
-          <a:prstGeom prst="homePlate">
-            <a:avLst/>
-          </a:prstGeom>
-          <a:solidFill>
-            <a:srgbClr val="8E44AD"/>
-          </a:solidFill>
-          <a:ln>
-            <a:noFill/>
-          </a:ln>
-          <a:effectLst/>
-        </p:spPr>
-        <p:style>
-          <a:lnRef idx="1">
-            <a:schemeClr val="accent1"/>
-          </a:lnRef>
-          <a:fillRef idx="3">
-            <a:schemeClr val="accent1"/>
-          </a:fillRef>
-          <a:effectRef idx="2">
-            <a:schemeClr val="accent1"/>
-          </a:effectRef>
-          <a:fontRef idx="minor">
-            <a:schemeClr val="lt1"/>
-          </a:fontRef>
-        </p:style>
-        <p:txBody>
-          <a:bodyPr rtlCol="0" anchor="ctr"/>
-          <a:lstStyle/>
-          <a:p>
-            <a:pPr algn="ctr"/>
-          </a:p>
-        </p:txBody>
-      </p:sp>
+      <p:pic>
+        <p:nvPicPr>
+          <p:cNvPr id="4" name="Picture 3" descr="logo_trim.png"/>
+          <p:cNvPicPr>
+            <a:picLocks noChangeAspect="1"/>
+          </p:cNvPicPr>
+          <p:nvPr/>
+        </p:nvPicPr>
+        <p:blipFill>
+          <a:blip r:embed="rId2"/>
+          <a:stretch>
+            <a:fillRect/>
+          </a:stretch>
+        </p:blipFill>
+        <p:spPr>
+          <a:xfrm>
+            <a:off x="822960" y="1280160"/>
+            <a:ext cx="691169" cy="822960"/>
+          </a:xfrm>
+          <a:prstGeom prst="rect">
+            <a:avLst/>
+          </a:prstGeom>
+        </p:spPr>
+      </p:pic>
       <p:sp>
         <p:nvSpPr>
           <p:cNvPr id="5" name="TextBox 4"/>
@@ -6908,9 +6892,33 @@
           </a:p>
         </p:txBody>
       </p:sp>
-      <p:sp>
-        <p:nvSpPr>
-          <p:cNvPr id="12" name="TextBox 11"/>
+      <p:pic>
+        <p:nvPicPr>
+          <p:cNvPr id="12" name="Picture 11" descr="logo_trim.png"/>
+          <p:cNvPicPr>
+            <a:picLocks noChangeAspect="1"/>
+          </p:cNvPicPr>
+          <p:nvPr/>
+        </p:nvPicPr>
+        <p:blipFill>
+          <a:blip r:embed="rId2"/>
+          <a:stretch>
+            <a:fillRect/>
+          </a:stretch>
+        </p:blipFill>
+        <p:spPr>
+          <a:xfrm>
+            <a:off x="11539728" y="457200"/>
+            <a:ext cx="307186" cy="365760"/>
+          </a:xfrm>
+          <a:prstGeom prst="rect">
+            <a:avLst/>
+          </a:prstGeom>
+        </p:spPr>
+      </p:pic>
+      <p:sp>
+        <p:nvSpPr>
+          <p:cNvPr id="13" name="TextBox 12"/>
           <p:cNvSpPr txBox="1"/>
           <p:nvPr/>
         </p:nvSpPr>
@@ -6955,7 +6963,7 @@
       </p:sp>
       <p:sp>
         <p:nvSpPr>
-          <p:cNvPr id="13" name="TextBox 12"/>
+          <p:cNvPr id="14" name="TextBox 13"/>
           <p:cNvSpPr txBox="1"/>
           <p:nvPr/>
         </p:nvSpPr>
@@ -8059,9 +8067,33 @@
           </a:p>
         </p:txBody>
       </p:sp>
-      <p:sp>
-        <p:nvSpPr>
-          <p:cNvPr id="21" name="TextBox 20"/>
+      <p:pic>
+        <p:nvPicPr>
+          <p:cNvPr id="21" name="Picture 20" descr="logo_trim.png"/>
+          <p:cNvPicPr>
+            <a:picLocks noChangeAspect="1"/>
+          </p:cNvPicPr>
+          <p:nvPr/>
+        </p:nvPicPr>
+        <p:blipFill>
+          <a:blip r:embed="rId2"/>
+          <a:stretch>
+            <a:fillRect/>
+          </a:stretch>
+        </p:blipFill>
+        <p:spPr>
+          <a:xfrm>
+            <a:off x="11539728" y="457200"/>
+            <a:ext cx="307186" cy="365760"/>
+          </a:xfrm>
+          <a:prstGeom prst="rect">
+            <a:avLst/>
+          </a:prstGeom>
+        </p:spPr>
+      </p:pic>
+      <p:sp>
+        <p:nvSpPr>
+          <p:cNvPr id="22" name="TextBox 21"/>
           <p:cNvSpPr txBox="1"/>
           <p:nvPr/>
         </p:nvSpPr>
@@ -8106,7 +8138,7 @@
       </p:sp>
       <p:sp>
         <p:nvSpPr>
-          <p:cNvPr id="22" name="TextBox 21"/>
+          <p:cNvPr id="23" name="TextBox 22"/>
           <p:cNvSpPr txBox="1"/>
           <p:nvPr/>
         </p:nvSpPr>
@@ -8799,9 +8831,33 @@
           </a:p>
         </p:txBody>
       </p:sp>
-      <p:sp>
-        <p:nvSpPr>
-          <p:cNvPr id="13" name="TextBox 12"/>
+      <p:pic>
+        <p:nvPicPr>
+          <p:cNvPr id="13" name="Picture 12" descr="logo_trim.png"/>
+          <p:cNvPicPr>
+            <a:picLocks noChangeAspect="1"/>
+          </p:cNvPicPr>
+          <p:nvPr/>
+        </p:nvPicPr>
+        <p:blipFill>
+          <a:blip r:embed="rId2"/>
+          <a:stretch>
+            <a:fillRect/>
+          </a:stretch>
+        </p:blipFill>
+        <p:spPr>
+          <a:xfrm>
+            <a:off x="11539728" y="457200"/>
+            <a:ext cx="307186" cy="365760"/>
+          </a:xfrm>
+          <a:prstGeom prst="rect">
+            <a:avLst/>
+          </a:prstGeom>
+        </p:spPr>
+      </p:pic>
+      <p:sp>
+        <p:nvSpPr>
+          <p:cNvPr id="14" name="TextBox 13"/>
           <p:cNvSpPr txBox="1"/>
           <p:nvPr/>
         </p:nvSpPr>
@@ -8846,7 +8902,7 @@
       </p:sp>
       <p:sp>
         <p:nvSpPr>
-          <p:cNvPr id="14" name="TextBox 13"/>
+          <p:cNvPr id="15" name="TextBox 14"/>
           <p:cNvSpPr txBox="1"/>
           <p:nvPr/>
         </p:nvSpPr>
@@ -9957,9 +10013,33 @@
           </a:p>
         </p:txBody>
       </p:sp>
-      <p:sp>
-        <p:nvSpPr>
-          <p:cNvPr id="25" name="TextBox 24"/>
+      <p:pic>
+        <p:nvPicPr>
+          <p:cNvPr id="25" name="Picture 24" descr="logo_trim.png"/>
+          <p:cNvPicPr>
+            <a:picLocks noChangeAspect="1"/>
+          </p:cNvPicPr>
+          <p:nvPr/>
+        </p:nvPicPr>
+        <p:blipFill>
+          <a:blip r:embed="rId2"/>
+          <a:stretch>
+            <a:fillRect/>
+          </a:stretch>
+        </p:blipFill>
+        <p:spPr>
+          <a:xfrm>
+            <a:off x="11539728" y="457200"/>
+            <a:ext cx="307186" cy="365760"/>
+          </a:xfrm>
+          <a:prstGeom prst="rect">
+            <a:avLst/>
+          </a:prstGeom>
+        </p:spPr>
+      </p:pic>
+      <p:sp>
+        <p:nvSpPr>
+          <p:cNvPr id="26" name="TextBox 25"/>
           <p:cNvSpPr txBox="1"/>
           <p:nvPr/>
         </p:nvSpPr>
@@ -10004,7 +10084,7 @@
       </p:sp>
       <p:sp>
         <p:nvSpPr>
-          <p:cNvPr id="26" name="TextBox 25"/>
+          <p:cNvPr id="27" name="TextBox 26"/>
           <p:cNvSpPr txBox="1"/>
           <p:nvPr/>
         </p:nvSpPr>
@@ -11153,9 +11233,33 @@
           </a:p>
         </p:txBody>
       </p:sp>
-      <p:sp>
-        <p:nvSpPr>
-          <p:cNvPr id="23" name="TextBox 22"/>
+      <p:pic>
+        <p:nvPicPr>
+          <p:cNvPr id="23" name="Picture 22" descr="logo_trim.png"/>
+          <p:cNvPicPr>
+            <a:picLocks noChangeAspect="1"/>
+          </p:cNvPicPr>
+          <p:nvPr/>
+        </p:nvPicPr>
+        <p:blipFill>
+          <a:blip r:embed="rId2"/>
+          <a:stretch>
+            <a:fillRect/>
+          </a:stretch>
+        </p:blipFill>
+        <p:spPr>
+          <a:xfrm>
+            <a:off x="11539728" y="457200"/>
+            <a:ext cx="307186" cy="365760"/>
+          </a:xfrm>
+          <a:prstGeom prst="rect">
+            <a:avLst/>
+          </a:prstGeom>
+        </p:spPr>
+      </p:pic>
+      <p:sp>
+        <p:nvSpPr>
+          <p:cNvPr id="24" name="TextBox 23"/>
           <p:cNvSpPr txBox="1"/>
           <p:nvPr/>
         </p:nvSpPr>
@@ -11200,7 +11304,7 @@
       </p:sp>
       <p:sp>
         <p:nvSpPr>
-          <p:cNvPr id="24" name="TextBox 23"/>
+          <p:cNvPr id="25" name="TextBox 24"/>
           <p:cNvSpPr txBox="1"/>
           <p:nvPr/>
         </p:nvSpPr>
@@ -12769,9 +12873,33 @@
           </a:p>
         </p:txBody>
       </p:sp>
-      <p:sp>
-        <p:nvSpPr>
-          <p:cNvPr id="27" name="TextBox 26"/>
+      <p:pic>
+        <p:nvPicPr>
+          <p:cNvPr id="27" name="Picture 26" descr="logo_trim.png"/>
+          <p:cNvPicPr>
+            <a:picLocks noChangeAspect="1"/>
+          </p:cNvPicPr>
+          <p:nvPr/>
+        </p:nvPicPr>
+        <p:blipFill>
+          <a:blip r:embed="rId2"/>
+          <a:stretch>
+            <a:fillRect/>
+          </a:stretch>
+        </p:blipFill>
+        <p:spPr>
+          <a:xfrm>
+            <a:off x="11539728" y="457200"/>
+            <a:ext cx="307186" cy="365760"/>
+          </a:xfrm>
+          <a:prstGeom prst="rect">
+            <a:avLst/>
+          </a:prstGeom>
+        </p:spPr>
+      </p:pic>
+      <p:sp>
+        <p:nvSpPr>
+          <p:cNvPr id="28" name="TextBox 27"/>
           <p:cNvSpPr txBox="1"/>
           <p:nvPr/>
         </p:nvSpPr>
@@ -12816,7 +12944,7 @@
       </p:sp>
       <p:sp>
         <p:nvSpPr>
-          <p:cNvPr id="28" name="TextBox 27"/>
+          <p:cNvPr id="29" name="TextBox 28"/>
           <p:cNvSpPr txBox="1"/>
           <p:nvPr/>
         </p:nvSpPr>
@@ -14044,9 +14172,33 @@
           </a:p>
         </p:txBody>
       </p:sp>
-      <p:sp>
-        <p:nvSpPr>
-          <p:cNvPr id="22" name="TextBox 21"/>
+      <p:pic>
+        <p:nvPicPr>
+          <p:cNvPr id="22" name="Picture 21" descr="logo_trim.png"/>
+          <p:cNvPicPr>
+            <a:picLocks noChangeAspect="1"/>
+          </p:cNvPicPr>
+          <p:nvPr/>
+        </p:nvPicPr>
+        <p:blipFill>
+          <a:blip r:embed="rId2"/>
+          <a:stretch>
+            <a:fillRect/>
+          </a:stretch>
+        </p:blipFill>
+        <p:spPr>
+          <a:xfrm>
+            <a:off x="11539728" y="457200"/>
+            <a:ext cx="307186" cy="365760"/>
+          </a:xfrm>
+          <a:prstGeom prst="rect">
+            <a:avLst/>
+          </a:prstGeom>
+        </p:spPr>
+      </p:pic>
+      <p:sp>
+        <p:nvSpPr>
+          <p:cNvPr id="23" name="TextBox 22"/>
           <p:cNvSpPr txBox="1"/>
           <p:nvPr/>
         </p:nvSpPr>
@@ -14091,7 +14243,7 @@
       </p:sp>
       <p:sp>
         <p:nvSpPr>
-          <p:cNvPr id="23" name="TextBox 22"/>
+          <p:cNvPr id="24" name="TextBox 23"/>
           <p:cNvSpPr txBox="1"/>
           <p:nvPr/>
         </p:nvSpPr>
@@ -14944,9 +15096,33 @@
           </a:p>
         </p:txBody>
       </p:sp>
-      <p:sp>
-        <p:nvSpPr>
-          <p:cNvPr id="15" name="TextBox 14"/>
+      <p:pic>
+        <p:nvPicPr>
+          <p:cNvPr id="15" name="Picture 14" descr="logo_trim.png"/>
+          <p:cNvPicPr>
+            <a:picLocks noChangeAspect="1"/>
+          </p:cNvPicPr>
+          <p:nvPr/>
+        </p:nvPicPr>
+        <p:blipFill>
+          <a:blip r:embed="rId2"/>
+          <a:stretch>
+            <a:fillRect/>
+          </a:stretch>
+        </p:blipFill>
+        <p:spPr>
+          <a:xfrm>
+            <a:off x="11539728" y="457200"/>
+            <a:ext cx="307186" cy="365760"/>
+          </a:xfrm>
+          <a:prstGeom prst="rect">
+            <a:avLst/>
+          </a:prstGeom>
+        </p:spPr>
+      </p:pic>
+      <p:sp>
+        <p:nvSpPr>
+          <p:cNvPr id="16" name="TextBox 15"/>
           <p:cNvSpPr txBox="1"/>
           <p:nvPr/>
         </p:nvSpPr>
@@ -14991,7 +15167,7 @@
       </p:sp>
       <p:sp>
         <p:nvSpPr>
-          <p:cNvPr id="16" name="TextBox 15"/>
+          <p:cNvPr id="17" name="TextBox 16"/>
           <p:cNvSpPr txBox="1"/>
           <p:nvPr/>
         </p:nvSpPr>

</xml_diff>

<commit_message>
fix(pitch): use real slide background so Google Slides edit mode renders
The deck drew each slide's background as a full-slide rectangle shape.
PowerPoint, the Google Slides thumbnail rail, and Slideshow all render
that fine, but the Google Slides EDIT canvas blanks out on a shape that
exactly covers the slide. Switched slide() to set the actual slide
background fill (p:bg) instead — no full-cover rectangles remain.

Co-Authored-By: Claude Opus 4.8 <noreply@anthropic.com>
Claude-Session: https://claude.ai/code/session_01EiquWdpoHJaLq9xBqbbKr9
</commit_message>
<xml_diff>
--- a/docs/pitch-deck-v3.pptx
+++ b/docs/pitch-deck-v3.pptx
@@ -4211,6 +4211,14 @@
 <file path=ppt/slides/slide1.xml><?xml version="1.0" encoding="utf-8"?>
 <p:sld xmlns:a="http://schemas.openxmlformats.org/drawingml/2006/main" xmlns:p="http://schemas.openxmlformats.org/presentationml/2006/main" xmlns:r="http://schemas.openxmlformats.org/officeDocument/2006/relationships">
   <p:cSld>
+    <p:bg>
+      <p:bgPr>
+        <a:solidFill>
+          <a:srgbClr val="1A1025"/>
+        </a:solidFill>
+        <a:effectLst/>
+      </p:bgPr>
+    </p:bg>
     <p:spTree>
       <p:nvGrpSpPr>
         <p:cNvPr id="1" name=""/>
@@ -4227,50 +4235,6 @@
         <p:spPr>
           <a:xfrm>
             <a:off x="0" y="0"/>
-            <a:ext cx="12191695" cy="6858000"/>
-          </a:xfrm>
-          <a:prstGeom prst="rect">
-            <a:avLst/>
-          </a:prstGeom>
-          <a:solidFill>
-            <a:srgbClr val="1A1025"/>
-          </a:solidFill>
-          <a:ln>
-            <a:noFill/>
-          </a:ln>
-          <a:effectLst/>
-        </p:spPr>
-        <p:style>
-          <a:lnRef idx="1">
-            <a:schemeClr val="accent1"/>
-          </a:lnRef>
-          <a:fillRef idx="3">
-            <a:schemeClr val="accent1"/>
-          </a:fillRef>
-          <a:effectRef idx="2">
-            <a:schemeClr val="accent1"/>
-          </a:effectRef>
-          <a:fontRef idx="minor">
-            <a:schemeClr val="lt1"/>
-          </a:fontRef>
-        </p:style>
-        <p:txBody>
-          <a:bodyPr rtlCol="0" anchor="ctr"/>
-          <a:lstStyle/>
-          <a:p>
-            <a:pPr algn="ctr"/>
-          </a:p>
-        </p:txBody>
-      </p:sp>
-      <p:sp>
-        <p:nvSpPr>
-          <p:cNvPr id="3" name="Rectangle 2"/>
-          <p:cNvSpPr/>
-          <p:nvPr/>
-        </p:nvSpPr>
-        <p:spPr>
-          <a:xfrm>
-            <a:off x="0" y="0"/>
             <a:ext cx="11148085908000" cy="128016"/>
           </a:xfrm>
           <a:prstGeom prst="rect">
@@ -4308,7 +4272,7 @@
       </p:sp>
       <p:pic>
         <p:nvPicPr>
-          <p:cNvPr id="4" name="Picture 3" descr="logo_trim.png"/>
+          <p:cNvPr id="3" name="Picture 2" descr="logo_trim.png"/>
           <p:cNvPicPr>
             <a:picLocks noChangeAspect="1"/>
           </p:cNvPicPr>
@@ -4332,7 +4296,7 @@
       </p:pic>
       <p:sp>
         <p:nvSpPr>
-          <p:cNvPr id="5" name="TextBox 4"/>
+          <p:cNvPr id="4" name="TextBox 3"/>
           <p:cNvSpPr txBox="1"/>
           <p:nvPr/>
         </p:nvSpPr>
@@ -4377,7 +4341,7 @@
       </p:sp>
       <p:sp>
         <p:nvSpPr>
-          <p:cNvPr id="6" name="TextBox 5"/>
+          <p:cNvPr id="5" name="TextBox 4"/>
           <p:cNvSpPr txBox="1"/>
           <p:nvPr/>
         </p:nvSpPr>
@@ -4444,7 +4408,7 @@
       </p:sp>
       <p:sp>
         <p:nvSpPr>
-          <p:cNvPr id="7" name="Rounded Rectangle 6"/>
+          <p:cNvPr id="6" name="Rounded Rectangle 5"/>
           <p:cNvSpPr/>
           <p:nvPr/>
         </p:nvSpPr>
@@ -4490,7 +4454,7 @@
       </p:sp>
       <p:sp>
         <p:nvSpPr>
-          <p:cNvPr id="8" name="TextBox 7"/>
+          <p:cNvPr id="7" name="TextBox 6"/>
           <p:cNvSpPr txBox="1"/>
           <p:nvPr/>
         </p:nvSpPr>
@@ -4535,7 +4499,7 @@
       </p:sp>
       <p:sp>
         <p:nvSpPr>
-          <p:cNvPr id="9" name="Rounded Rectangle 8"/>
+          <p:cNvPr id="8" name="Rounded Rectangle 7"/>
           <p:cNvSpPr/>
           <p:nvPr/>
         </p:nvSpPr>
@@ -4581,7 +4545,7 @@
       </p:sp>
       <p:sp>
         <p:nvSpPr>
-          <p:cNvPr id="10" name="TextBox 9"/>
+          <p:cNvPr id="9" name="TextBox 8"/>
           <p:cNvSpPr txBox="1"/>
           <p:nvPr/>
         </p:nvSpPr>
@@ -4626,7 +4590,7 @@
       </p:sp>
       <p:sp>
         <p:nvSpPr>
-          <p:cNvPr id="11" name="Rounded Rectangle 10"/>
+          <p:cNvPr id="10" name="Rounded Rectangle 9"/>
           <p:cNvSpPr/>
           <p:nvPr/>
         </p:nvSpPr>
@@ -4672,7 +4636,7 @@
       </p:sp>
       <p:sp>
         <p:nvSpPr>
-          <p:cNvPr id="12" name="TextBox 11"/>
+          <p:cNvPr id="11" name="TextBox 10"/>
           <p:cNvSpPr txBox="1"/>
           <p:nvPr/>
         </p:nvSpPr>
@@ -4717,7 +4681,7 @@
       </p:sp>
       <p:sp>
         <p:nvSpPr>
-          <p:cNvPr id="13" name="TextBox 12"/>
+          <p:cNvPr id="12" name="TextBox 11"/>
           <p:cNvSpPr txBox="1"/>
           <p:nvPr/>
         </p:nvSpPr>
@@ -4771,6 +4735,14 @@
 <file path=ppt/slides/slide10.xml><?xml version="1.0" encoding="utf-8"?>
 <p:sld xmlns:a="http://schemas.openxmlformats.org/drawingml/2006/main" xmlns:p="http://schemas.openxmlformats.org/presentationml/2006/main" xmlns:r="http://schemas.openxmlformats.org/officeDocument/2006/relationships">
   <p:cSld>
+    <p:bg>
+      <p:bgPr>
+        <a:solidFill>
+          <a:srgbClr val="1A1025"/>
+        </a:solidFill>
+        <a:effectLst/>
+      </p:bgPr>
+    </p:bg>
     <p:spTree>
       <p:nvGrpSpPr>
         <p:cNvPr id="1" name=""/>
@@ -4780,51 +4752,7 @@
       <p:grpSpPr/>
       <p:sp>
         <p:nvSpPr>
-          <p:cNvPr id="2" name="Rectangle 1"/>
-          <p:cNvSpPr/>
-          <p:nvPr/>
-        </p:nvSpPr>
-        <p:spPr>
-          <a:xfrm>
-            <a:off x="0" y="0"/>
-            <a:ext cx="12191695" cy="6858000"/>
-          </a:xfrm>
-          <a:prstGeom prst="rect">
-            <a:avLst/>
-          </a:prstGeom>
-          <a:solidFill>
-            <a:srgbClr val="1A1025"/>
-          </a:solidFill>
-          <a:ln>
-            <a:noFill/>
-          </a:ln>
-          <a:effectLst/>
-        </p:spPr>
-        <p:style>
-          <a:lnRef idx="1">
-            <a:schemeClr val="accent1"/>
-          </a:lnRef>
-          <a:fillRef idx="3">
-            <a:schemeClr val="accent1"/>
-          </a:fillRef>
-          <a:effectRef idx="2">
-            <a:schemeClr val="accent1"/>
-          </a:effectRef>
-          <a:fontRef idx="minor">
-            <a:schemeClr val="lt1"/>
-          </a:fontRef>
-        </p:style>
-        <p:txBody>
-          <a:bodyPr rtlCol="0" anchor="ctr"/>
-          <a:lstStyle/>
-          <a:p>
-            <a:pPr algn="ctr"/>
-          </a:p>
-        </p:txBody>
-      </p:sp>
-      <p:sp>
-        <p:nvSpPr>
-          <p:cNvPr id="3" name="TextBox 2"/>
+          <p:cNvPr id="2" name="TextBox 1"/>
           <p:cNvSpPr txBox="1"/>
           <p:nvPr/>
         </p:nvSpPr>
@@ -4869,7 +4797,7 @@
       </p:sp>
       <p:sp>
         <p:nvSpPr>
-          <p:cNvPr id="4" name="TextBox 3"/>
+          <p:cNvPr id="3" name="TextBox 2"/>
           <p:cNvSpPr txBox="1"/>
           <p:nvPr/>
         </p:nvSpPr>
@@ -4914,7 +4842,7 @@
       </p:sp>
       <p:sp>
         <p:nvSpPr>
-          <p:cNvPr id="5" name="Rounded Rectangle 4"/>
+          <p:cNvPr id="4" name="Rounded Rectangle 3"/>
           <p:cNvSpPr/>
           <p:nvPr/>
         </p:nvSpPr>
@@ -4962,7 +4890,7 @@
       </p:sp>
       <p:sp>
         <p:nvSpPr>
-          <p:cNvPr id="6" name="Rectangle 5"/>
+          <p:cNvPr id="5" name="Rectangle 4"/>
           <p:cNvSpPr/>
           <p:nvPr/>
         </p:nvSpPr>
@@ -5006,7 +4934,7 @@
       </p:sp>
       <p:sp>
         <p:nvSpPr>
-          <p:cNvPr id="7" name="TextBox 6"/>
+          <p:cNvPr id="6" name="TextBox 5"/>
           <p:cNvSpPr txBox="1"/>
           <p:nvPr/>
         </p:nvSpPr>
@@ -5051,7 +4979,7 @@
       </p:sp>
       <p:sp>
         <p:nvSpPr>
-          <p:cNvPr id="8" name="TextBox 7"/>
+          <p:cNvPr id="7" name="TextBox 6"/>
           <p:cNvSpPr txBox="1"/>
           <p:nvPr/>
         </p:nvSpPr>
@@ -5096,7 +5024,7 @@
       </p:sp>
       <p:sp>
         <p:nvSpPr>
-          <p:cNvPr id="9" name="Rounded Rectangle 8"/>
+          <p:cNvPr id="8" name="Rounded Rectangle 7"/>
           <p:cNvSpPr/>
           <p:nvPr/>
         </p:nvSpPr>
@@ -5142,7 +5070,7 @@
       </p:sp>
       <p:sp>
         <p:nvSpPr>
-          <p:cNvPr id="10" name="Rectangle 9"/>
+          <p:cNvPr id="9" name="Rectangle 8"/>
           <p:cNvSpPr/>
           <p:nvPr/>
         </p:nvSpPr>
@@ -5186,7 +5114,7 @@
       </p:sp>
       <p:sp>
         <p:nvSpPr>
-          <p:cNvPr id="11" name="TextBox 10"/>
+          <p:cNvPr id="10" name="TextBox 9"/>
           <p:cNvSpPr txBox="1"/>
           <p:nvPr/>
         </p:nvSpPr>
@@ -5231,7 +5159,7 @@
       </p:sp>
       <p:sp>
         <p:nvSpPr>
-          <p:cNvPr id="12" name="TextBox 11"/>
+          <p:cNvPr id="11" name="TextBox 10"/>
           <p:cNvSpPr txBox="1"/>
           <p:nvPr/>
         </p:nvSpPr>
@@ -5276,7 +5204,7 @@
       </p:sp>
       <p:sp>
         <p:nvSpPr>
-          <p:cNvPr id="13" name="Rounded Rectangle 12"/>
+          <p:cNvPr id="12" name="Rounded Rectangle 11"/>
           <p:cNvSpPr/>
           <p:nvPr/>
         </p:nvSpPr>
@@ -5322,7 +5250,7 @@
       </p:sp>
       <p:sp>
         <p:nvSpPr>
-          <p:cNvPr id="14" name="Rectangle 13"/>
+          <p:cNvPr id="13" name="Rectangle 12"/>
           <p:cNvSpPr/>
           <p:nvPr/>
         </p:nvSpPr>
@@ -5366,7 +5294,7 @@
       </p:sp>
       <p:sp>
         <p:nvSpPr>
-          <p:cNvPr id="15" name="TextBox 14"/>
+          <p:cNvPr id="14" name="TextBox 13"/>
           <p:cNvSpPr txBox="1"/>
           <p:nvPr/>
         </p:nvSpPr>
@@ -5411,7 +5339,7 @@
       </p:sp>
       <p:sp>
         <p:nvSpPr>
-          <p:cNvPr id="16" name="TextBox 15"/>
+          <p:cNvPr id="15" name="TextBox 14"/>
           <p:cNvSpPr txBox="1"/>
           <p:nvPr/>
         </p:nvSpPr>
@@ -5456,7 +5384,7 @@
       </p:sp>
       <p:sp>
         <p:nvSpPr>
-          <p:cNvPr id="17" name="Rounded Rectangle 16"/>
+          <p:cNvPr id="16" name="Rounded Rectangle 15"/>
           <p:cNvSpPr/>
           <p:nvPr/>
         </p:nvSpPr>
@@ -5502,7 +5430,7 @@
       </p:sp>
       <p:sp>
         <p:nvSpPr>
-          <p:cNvPr id="18" name="Rectangle 17"/>
+          <p:cNvPr id="17" name="Rectangle 16"/>
           <p:cNvSpPr/>
           <p:nvPr/>
         </p:nvSpPr>
@@ -5546,7 +5474,7 @@
       </p:sp>
       <p:sp>
         <p:nvSpPr>
-          <p:cNvPr id="19" name="TextBox 18"/>
+          <p:cNvPr id="18" name="TextBox 17"/>
           <p:cNvSpPr txBox="1"/>
           <p:nvPr/>
         </p:nvSpPr>
@@ -5591,7 +5519,7 @@
       </p:sp>
       <p:sp>
         <p:nvSpPr>
-          <p:cNvPr id="20" name="TextBox 19"/>
+          <p:cNvPr id="19" name="TextBox 18"/>
           <p:cNvSpPr txBox="1"/>
           <p:nvPr/>
         </p:nvSpPr>
@@ -5636,7 +5564,7 @@
       </p:sp>
       <p:pic>
         <p:nvPicPr>
-          <p:cNvPr id="21" name="Picture 20" descr="logo_trim.png"/>
+          <p:cNvPr id="20" name="Picture 19" descr="logo_trim.png"/>
           <p:cNvPicPr>
             <a:picLocks noChangeAspect="1"/>
           </p:cNvPicPr>
@@ -5660,7 +5588,7 @@
       </p:pic>
       <p:sp>
         <p:nvSpPr>
-          <p:cNvPr id="22" name="TextBox 21"/>
+          <p:cNvPr id="21" name="TextBox 20"/>
           <p:cNvSpPr txBox="1"/>
           <p:nvPr/>
         </p:nvSpPr>
@@ -5705,7 +5633,7 @@
       </p:sp>
       <p:sp>
         <p:nvSpPr>
-          <p:cNvPr id="23" name="TextBox 22"/>
+          <p:cNvPr id="22" name="TextBox 21"/>
           <p:cNvSpPr txBox="1"/>
           <p:nvPr/>
         </p:nvSpPr>
@@ -5759,6 +5687,14 @@
 <file path=ppt/slides/slide11.xml><?xml version="1.0" encoding="utf-8"?>
 <p:sld xmlns:a="http://schemas.openxmlformats.org/drawingml/2006/main" xmlns:p="http://schemas.openxmlformats.org/presentationml/2006/main" xmlns:r="http://schemas.openxmlformats.org/officeDocument/2006/relationships">
   <p:cSld>
+    <p:bg>
+      <p:bgPr>
+        <a:solidFill>
+          <a:srgbClr val="1A1025"/>
+        </a:solidFill>
+        <a:effectLst/>
+      </p:bgPr>
+    </p:bg>
     <p:spTree>
       <p:nvGrpSpPr>
         <p:cNvPr id="1" name=""/>
@@ -5775,50 +5711,6 @@
         <p:spPr>
           <a:xfrm>
             <a:off x="0" y="0"/>
-            <a:ext cx="12191695" cy="6858000"/>
-          </a:xfrm>
-          <a:prstGeom prst="rect">
-            <a:avLst/>
-          </a:prstGeom>
-          <a:solidFill>
-            <a:srgbClr val="1A1025"/>
-          </a:solidFill>
-          <a:ln>
-            <a:noFill/>
-          </a:ln>
-          <a:effectLst/>
-        </p:spPr>
-        <p:style>
-          <a:lnRef idx="1">
-            <a:schemeClr val="accent1"/>
-          </a:lnRef>
-          <a:fillRef idx="3">
-            <a:schemeClr val="accent1"/>
-          </a:fillRef>
-          <a:effectRef idx="2">
-            <a:schemeClr val="accent1"/>
-          </a:effectRef>
-          <a:fontRef idx="minor">
-            <a:schemeClr val="lt1"/>
-          </a:fontRef>
-        </p:style>
-        <p:txBody>
-          <a:bodyPr rtlCol="0" anchor="ctr"/>
-          <a:lstStyle/>
-          <a:p>
-            <a:pPr algn="ctr"/>
-          </a:p>
-        </p:txBody>
-      </p:sp>
-      <p:sp>
-        <p:nvSpPr>
-          <p:cNvPr id="3" name="Rectangle 2"/>
-          <p:cNvSpPr/>
-          <p:nvPr/>
-        </p:nvSpPr>
-        <p:spPr>
-          <a:xfrm>
-            <a:off x="0" y="0"/>
             <a:ext cx="11148085908000" cy="128016"/>
           </a:xfrm>
           <a:prstGeom prst="rect">
@@ -5856,7 +5748,7 @@
       </p:sp>
       <p:pic>
         <p:nvPicPr>
-          <p:cNvPr id="4" name="Picture 3" descr="logo_trim.png"/>
+          <p:cNvPr id="3" name="Picture 2" descr="logo_trim.png"/>
           <p:cNvPicPr>
             <a:picLocks noChangeAspect="1"/>
           </p:cNvPicPr>
@@ -5880,7 +5772,7 @@
       </p:pic>
       <p:sp>
         <p:nvSpPr>
-          <p:cNvPr id="5" name="TextBox 4"/>
+          <p:cNvPr id="4" name="TextBox 3"/>
           <p:cNvSpPr txBox="1"/>
           <p:nvPr/>
         </p:nvSpPr>
@@ -5925,7 +5817,7 @@
       </p:sp>
       <p:sp>
         <p:nvSpPr>
-          <p:cNvPr id="6" name="TextBox 5"/>
+          <p:cNvPr id="5" name="TextBox 4"/>
           <p:cNvSpPr txBox="1"/>
           <p:nvPr/>
         </p:nvSpPr>
@@ -5970,7 +5862,7 @@
       </p:sp>
       <p:sp>
         <p:nvSpPr>
-          <p:cNvPr id="7" name="TextBox 6"/>
+          <p:cNvPr id="6" name="TextBox 5"/>
           <p:cNvSpPr txBox="1"/>
           <p:nvPr/>
         </p:nvSpPr>
@@ -6015,7 +5907,7 @@
       </p:sp>
       <p:sp>
         <p:nvSpPr>
-          <p:cNvPr id="8" name="Rounded Rectangle 7"/>
+          <p:cNvPr id="7" name="Rounded Rectangle 6"/>
           <p:cNvSpPr/>
           <p:nvPr/>
         </p:nvSpPr>
@@ -6061,7 +5953,7 @@
       </p:sp>
       <p:sp>
         <p:nvSpPr>
-          <p:cNvPr id="9" name="TextBox 8"/>
+          <p:cNvPr id="8" name="TextBox 7"/>
           <p:cNvSpPr txBox="1"/>
           <p:nvPr/>
         </p:nvSpPr>
@@ -6106,7 +5998,7 @@
       </p:sp>
       <p:sp>
         <p:nvSpPr>
-          <p:cNvPr id="10" name="Rounded Rectangle 9"/>
+          <p:cNvPr id="9" name="Rounded Rectangle 8"/>
           <p:cNvSpPr/>
           <p:nvPr/>
         </p:nvSpPr>
@@ -6152,7 +6044,7 @@
       </p:sp>
       <p:sp>
         <p:nvSpPr>
-          <p:cNvPr id="11" name="TextBox 10"/>
+          <p:cNvPr id="10" name="TextBox 9"/>
           <p:cNvSpPr txBox="1"/>
           <p:nvPr/>
         </p:nvSpPr>
@@ -6197,7 +6089,7 @@
       </p:sp>
       <p:sp>
         <p:nvSpPr>
-          <p:cNvPr id="12" name="TextBox 11"/>
+          <p:cNvPr id="11" name="TextBox 10"/>
           <p:cNvSpPr txBox="1"/>
           <p:nvPr/>
         </p:nvSpPr>
@@ -6251,6 +6143,14 @@
 <file path=ppt/slides/slide2.xml><?xml version="1.0" encoding="utf-8"?>
 <p:sld xmlns:a="http://schemas.openxmlformats.org/drawingml/2006/main" xmlns:p="http://schemas.openxmlformats.org/presentationml/2006/main" xmlns:r="http://schemas.openxmlformats.org/officeDocument/2006/relationships">
   <p:cSld>
+    <p:bg>
+      <p:bgPr>
+        <a:solidFill>
+          <a:srgbClr val="F7F9FB"/>
+        </a:solidFill>
+        <a:effectLst/>
+      </p:bgPr>
+    </p:bg>
     <p:spTree>
       <p:nvGrpSpPr>
         <p:cNvPr id="1" name=""/>
@@ -6260,51 +6160,7 @@
       <p:grpSpPr/>
       <p:sp>
         <p:nvSpPr>
-          <p:cNvPr id="2" name="Rectangle 1"/>
-          <p:cNvSpPr/>
-          <p:nvPr/>
-        </p:nvSpPr>
-        <p:spPr>
-          <a:xfrm>
-            <a:off x="0" y="0"/>
-            <a:ext cx="12191695" cy="6858000"/>
-          </a:xfrm>
-          <a:prstGeom prst="rect">
-            <a:avLst/>
-          </a:prstGeom>
-          <a:solidFill>
-            <a:srgbClr val="F7F9FB"/>
-          </a:solidFill>
-          <a:ln>
-            <a:noFill/>
-          </a:ln>
-          <a:effectLst/>
-        </p:spPr>
-        <p:style>
-          <a:lnRef idx="1">
-            <a:schemeClr val="accent1"/>
-          </a:lnRef>
-          <a:fillRef idx="3">
-            <a:schemeClr val="accent1"/>
-          </a:fillRef>
-          <a:effectRef idx="2">
-            <a:schemeClr val="accent1"/>
-          </a:effectRef>
-          <a:fontRef idx="minor">
-            <a:schemeClr val="lt1"/>
-          </a:fontRef>
-        </p:style>
-        <p:txBody>
-          <a:bodyPr rtlCol="0" anchor="ctr"/>
-          <a:lstStyle/>
-          <a:p>
-            <a:pPr algn="ctr"/>
-          </a:p>
-        </p:txBody>
-      </p:sp>
-      <p:sp>
-        <p:nvSpPr>
-          <p:cNvPr id="3" name="TextBox 2"/>
+          <p:cNvPr id="2" name="TextBox 1"/>
           <p:cNvSpPr txBox="1"/>
           <p:nvPr/>
         </p:nvSpPr>
@@ -6349,7 +6205,7 @@
       </p:sp>
       <p:sp>
         <p:nvSpPr>
-          <p:cNvPr id="4" name="TextBox 3"/>
+          <p:cNvPr id="3" name="TextBox 2"/>
           <p:cNvSpPr txBox="1"/>
           <p:nvPr/>
         </p:nvSpPr>
@@ -6394,7 +6250,7 @@
       </p:sp>
       <p:sp>
         <p:nvSpPr>
-          <p:cNvPr id="5" name="Rounded Rectangle 4"/>
+          <p:cNvPr id="4" name="Rounded Rectangle 3"/>
           <p:cNvSpPr/>
           <p:nvPr/>
         </p:nvSpPr>
@@ -6442,7 +6298,7 @@
       </p:sp>
       <p:sp>
         <p:nvSpPr>
-          <p:cNvPr id="6" name="TextBox 5"/>
+          <p:cNvPr id="5" name="TextBox 4"/>
           <p:cNvSpPr txBox="1"/>
           <p:nvPr/>
         </p:nvSpPr>
@@ -6619,7 +6475,7 @@
       </p:sp>
       <p:sp>
         <p:nvSpPr>
-          <p:cNvPr id="7" name="Rounded Rectangle 6"/>
+          <p:cNvPr id="6" name="Rounded Rectangle 5"/>
           <p:cNvSpPr/>
           <p:nvPr/>
         </p:nvSpPr>
@@ -6667,7 +6523,7 @@
       </p:sp>
       <p:sp>
         <p:nvSpPr>
-          <p:cNvPr id="8" name="TextBox 7"/>
+          <p:cNvPr id="7" name="TextBox 6"/>
           <p:cNvSpPr txBox="1"/>
           <p:nvPr/>
         </p:nvSpPr>
@@ -6734,7 +6590,7 @@
       </p:sp>
       <p:sp>
         <p:nvSpPr>
-          <p:cNvPr id="9" name="Rounded Rectangle 8"/>
+          <p:cNvPr id="8" name="Rounded Rectangle 7"/>
           <p:cNvSpPr/>
           <p:nvPr/>
         </p:nvSpPr>
@@ -6782,7 +6638,7 @@
       </p:sp>
       <p:sp>
         <p:nvSpPr>
-          <p:cNvPr id="10" name="TextBox 9"/>
+          <p:cNvPr id="9" name="TextBox 8"/>
           <p:cNvSpPr txBox="1"/>
           <p:nvPr/>
         </p:nvSpPr>
@@ -6849,7 +6705,7 @@
       </p:sp>
       <p:sp>
         <p:nvSpPr>
-          <p:cNvPr id="11" name="TextBox 10"/>
+          <p:cNvPr id="10" name="TextBox 9"/>
           <p:cNvSpPr txBox="1"/>
           <p:nvPr/>
         </p:nvSpPr>
@@ -6894,7 +6750,7 @@
       </p:sp>
       <p:pic>
         <p:nvPicPr>
-          <p:cNvPr id="12" name="Picture 11" descr="logo_trim.png"/>
+          <p:cNvPr id="11" name="Picture 10" descr="logo_trim.png"/>
           <p:cNvPicPr>
             <a:picLocks noChangeAspect="1"/>
           </p:cNvPicPr>
@@ -6918,7 +6774,7 @@
       </p:pic>
       <p:sp>
         <p:nvSpPr>
-          <p:cNvPr id="13" name="TextBox 12"/>
+          <p:cNvPr id="12" name="TextBox 11"/>
           <p:cNvSpPr txBox="1"/>
           <p:nvPr/>
         </p:nvSpPr>
@@ -6963,7 +6819,7 @@
       </p:sp>
       <p:sp>
         <p:nvSpPr>
-          <p:cNvPr id="14" name="TextBox 13"/>
+          <p:cNvPr id="13" name="TextBox 12"/>
           <p:cNvSpPr txBox="1"/>
           <p:nvPr/>
         </p:nvSpPr>
@@ -7017,6 +6873,14 @@
 <file path=ppt/slides/slide3.xml><?xml version="1.0" encoding="utf-8"?>
 <p:sld xmlns:a="http://schemas.openxmlformats.org/drawingml/2006/main" xmlns:p="http://schemas.openxmlformats.org/presentationml/2006/main" xmlns:r="http://schemas.openxmlformats.org/officeDocument/2006/relationships">
   <p:cSld>
+    <p:bg>
+      <p:bgPr>
+        <a:solidFill>
+          <a:srgbClr val="F7F9FB"/>
+        </a:solidFill>
+        <a:effectLst/>
+      </p:bgPr>
+    </p:bg>
     <p:spTree>
       <p:nvGrpSpPr>
         <p:cNvPr id="1" name=""/>
@@ -7026,51 +6890,7 @@
       <p:grpSpPr/>
       <p:sp>
         <p:nvSpPr>
-          <p:cNvPr id="2" name="Rectangle 1"/>
-          <p:cNvSpPr/>
-          <p:nvPr/>
-        </p:nvSpPr>
-        <p:spPr>
-          <a:xfrm>
-            <a:off x="0" y="0"/>
-            <a:ext cx="12191695" cy="6858000"/>
-          </a:xfrm>
-          <a:prstGeom prst="rect">
-            <a:avLst/>
-          </a:prstGeom>
-          <a:solidFill>
-            <a:srgbClr val="F7F9FB"/>
-          </a:solidFill>
-          <a:ln>
-            <a:noFill/>
-          </a:ln>
-          <a:effectLst/>
-        </p:spPr>
-        <p:style>
-          <a:lnRef idx="1">
-            <a:schemeClr val="accent1"/>
-          </a:lnRef>
-          <a:fillRef idx="3">
-            <a:schemeClr val="accent1"/>
-          </a:fillRef>
-          <a:effectRef idx="2">
-            <a:schemeClr val="accent1"/>
-          </a:effectRef>
-          <a:fontRef idx="minor">
-            <a:schemeClr val="lt1"/>
-          </a:fontRef>
-        </p:style>
-        <p:txBody>
-          <a:bodyPr rtlCol="0" anchor="ctr"/>
-          <a:lstStyle/>
-          <a:p>
-            <a:pPr algn="ctr"/>
-          </a:p>
-        </p:txBody>
-      </p:sp>
-      <p:sp>
-        <p:nvSpPr>
-          <p:cNvPr id="3" name="TextBox 2"/>
+          <p:cNvPr id="2" name="TextBox 1"/>
           <p:cNvSpPr txBox="1"/>
           <p:nvPr/>
         </p:nvSpPr>
@@ -7115,7 +6935,7 @@
       </p:sp>
       <p:sp>
         <p:nvSpPr>
-          <p:cNvPr id="4" name="TextBox 3"/>
+          <p:cNvPr id="3" name="TextBox 2"/>
           <p:cNvSpPr txBox="1"/>
           <p:nvPr/>
         </p:nvSpPr>
@@ -7160,7 +6980,7 @@
       </p:sp>
       <p:sp>
         <p:nvSpPr>
-          <p:cNvPr id="5" name="TextBox 4"/>
+          <p:cNvPr id="4" name="TextBox 3"/>
           <p:cNvSpPr txBox="1"/>
           <p:nvPr/>
         </p:nvSpPr>
@@ -7205,7 +7025,7 @@
       </p:sp>
       <p:sp>
         <p:nvSpPr>
-          <p:cNvPr id="6" name="Rounded Rectangle 5"/>
+          <p:cNvPr id="5" name="Rounded Rectangle 4"/>
           <p:cNvSpPr/>
           <p:nvPr/>
         </p:nvSpPr>
@@ -7253,7 +7073,7 @@
       </p:sp>
       <p:sp>
         <p:nvSpPr>
-          <p:cNvPr id="7" name="Rounded Rectangle 6"/>
+          <p:cNvPr id="6" name="Rounded Rectangle 5"/>
           <p:cNvSpPr/>
           <p:nvPr/>
         </p:nvSpPr>
@@ -7299,7 +7119,7 @@
       </p:sp>
       <p:sp>
         <p:nvSpPr>
-          <p:cNvPr id="8" name="TextBox 7"/>
+          <p:cNvPr id="7" name="TextBox 6"/>
           <p:cNvSpPr txBox="1"/>
           <p:nvPr/>
         </p:nvSpPr>
@@ -7388,7 +7208,7 @@
       </p:sp>
       <p:sp>
         <p:nvSpPr>
-          <p:cNvPr id="9" name="Right Arrow 8"/>
+          <p:cNvPr id="8" name="Right Arrow 7"/>
           <p:cNvSpPr/>
           <p:nvPr/>
         </p:nvSpPr>
@@ -7432,7 +7252,7 @@
       </p:sp>
       <p:sp>
         <p:nvSpPr>
-          <p:cNvPr id="10" name="Rounded Rectangle 9"/>
+          <p:cNvPr id="9" name="Rounded Rectangle 8"/>
           <p:cNvSpPr/>
           <p:nvPr/>
         </p:nvSpPr>
@@ -7480,7 +7300,7 @@
       </p:sp>
       <p:sp>
         <p:nvSpPr>
-          <p:cNvPr id="11" name="Rounded Rectangle 10"/>
+          <p:cNvPr id="10" name="Rounded Rectangle 9"/>
           <p:cNvSpPr/>
           <p:nvPr/>
         </p:nvSpPr>
@@ -7526,7 +7346,7 @@
       </p:sp>
       <p:sp>
         <p:nvSpPr>
-          <p:cNvPr id="12" name="TextBox 11"/>
+          <p:cNvPr id="11" name="TextBox 10"/>
           <p:cNvSpPr txBox="1"/>
           <p:nvPr/>
         </p:nvSpPr>
@@ -7615,7 +7435,7 @@
       </p:sp>
       <p:sp>
         <p:nvSpPr>
-          <p:cNvPr id="13" name="Right Arrow 12"/>
+          <p:cNvPr id="12" name="Right Arrow 11"/>
           <p:cNvSpPr/>
           <p:nvPr/>
         </p:nvSpPr>
@@ -7659,7 +7479,7 @@
       </p:sp>
       <p:sp>
         <p:nvSpPr>
-          <p:cNvPr id="14" name="Rounded Rectangle 13"/>
+          <p:cNvPr id="13" name="Rounded Rectangle 12"/>
           <p:cNvSpPr/>
           <p:nvPr/>
         </p:nvSpPr>
@@ -7707,7 +7527,7 @@
       </p:sp>
       <p:sp>
         <p:nvSpPr>
-          <p:cNvPr id="15" name="Rounded Rectangle 14"/>
+          <p:cNvPr id="14" name="Rounded Rectangle 13"/>
           <p:cNvSpPr/>
           <p:nvPr/>
         </p:nvSpPr>
@@ -7753,7 +7573,7 @@
       </p:sp>
       <p:sp>
         <p:nvSpPr>
-          <p:cNvPr id="16" name="TextBox 15"/>
+          <p:cNvPr id="15" name="TextBox 14"/>
           <p:cNvSpPr txBox="1"/>
           <p:nvPr/>
         </p:nvSpPr>
@@ -7842,7 +7662,7 @@
       </p:sp>
       <p:sp>
         <p:nvSpPr>
-          <p:cNvPr id="17" name="Right Arrow 16"/>
+          <p:cNvPr id="16" name="Right Arrow 15"/>
           <p:cNvSpPr/>
           <p:nvPr/>
         </p:nvSpPr>
@@ -7886,7 +7706,7 @@
       </p:sp>
       <p:sp>
         <p:nvSpPr>
-          <p:cNvPr id="18" name="Rounded Rectangle 17"/>
+          <p:cNvPr id="17" name="Rounded Rectangle 16"/>
           <p:cNvSpPr/>
           <p:nvPr/>
         </p:nvSpPr>
@@ -7934,7 +7754,7 @@
       </p:sp>
       <p:sp>
         <p:nvSpPr>
-          <p:cNvPr id="19" name="Rounded Rectangle 18"/>
+          <p:cNvPr id="18" name="Rounded Rectangle 17"/>
           <p:cNvSpPr/>
           <p:nvPr/>
         </p:nvSpPr>
@@ -7980,7 +7800,7 @@
       </p:sp>
       <p:sp>
         <p:nvSpPr>
-          <p:cNvPr id="20" name="TextBox 19"/>
+          <p:cNvPr id="19" name="TextBox 18"/>
           <p:cNvSpPr txBox="1"/>
           <p:nvPr/>
         </p:nvSpPr>
@@ -8069,7 +7889,7 @@
       </p:sp>
       <p:pic>
         <p:nvPicPr>
-          <p:cNvPr id="21" name="Picture 20" descr="logo_trim.png"/>
+          <p:cNvPr id="20" name="Picture 19" descr="logo_trim.png"/>
           <p:cNvPicPr>
             <a:picLocks noChangeAspect="1"/>
           </p:cNvPicPr>
@@ -8093,7 +7913,7 @@
       </p:pic>
       <p:sp>
         <p:nvSpPr>
-          <p:cNvPr id="22" name="TextBox 21"/>
+          <p:cNvPr id="21" name="TextBox 20"/>
           <p:cNvSpPr txBox="1"/>
           <p:nvPr/>
         </p:nvSpPr>
@@ -8138,7 +7958,7 @@
       </p:sp>
       <p:sp>
         <p:nvSpPr>
-          <p:cNvPr id="23" name="TextBox 22"/>
+          <p:cNvPr id="22" name="TextBox 21"/>
           <p:cNvSpPr txBox="1"/>
           <p:nvPr/>
         </p:nvSpPr>
@@ -8192,6 +8012,14 @@
 <file path=ppt/slides/slide4.xml><?xml version="1.0" encoding="utf-8"?>
 <p:sld xmlns:a="http://schemas.openxmlformats.org/drawingml/2006/main" xmlns:p="http://schemas.openxmlformats.org/presentationml/2006/main" xmlns:r="http://schemas.openxmlformats.org/officeDocument/2006/relationships">
   <p:cSld>
+    <p:bg>
+      <p:bgPr>
+        <a:solidFill>
+          <a:srgbClr val="1A1025"/>
+        </a:solidFill>
+        <a:effectLst/>
+      </p:bgPr>
+    </p:bg>
     <p:spTree>
       <p:nvGrpSpPr>
         <p:cNvPr id="1" name=""/>
@@ -8201,51 +8029,7 @@
       <p:grpSpPr/>
       <p:sp>
         <p:nvSpPr>
-          <p:cNvPr id="2" name="Rectangle 1"/>
-          <p:cNvSpPr/>
-          <p:nvPr/>
-        </p:nvSpPr>
-        <p:spPr>
-          <a:xfrm>
-            <a:off x="0" y="0"/>
-            <a:ext cx="12191695" cy="6858000"/>
-          </a:xfrm>
-          <a:prstGeom prst="rect">
-            <a:avLst/>
-          </a:prstGeom>
-          <a:solidFill>
-            <a:srgbClr val="1A1025"/>
-          </a:solidFill>
-          <a:ln>
-            <a:noFill/>
-          </a:ln>
-          <a:effectLst/>
-        </p:spPr>
-        <p:style>
-          <a:lnRef idx="1">
-            <a:schemeClr val="accent1"/>
-          </a:lnRef>
-          <a:fillRef idx="3">
-            <a:schemeClr val="accent1"/>
-          </a:fillRef>
-          <a:effectRef idx="2">
-            <a:schemeClr val="accent1"/>
-          </a:effectRef>
-          <a:fontRef idx="minor">
-            <a:schemeClr val="lt1"/>
-          </a:fontRef>
-        </p:style>
-        <p:txBody>
-          <a:bodyPr rtlCol="0" anchor="ctr"/>
-          <a:lstStyle/>
-          <a:p>
-            <a:pPr algn="ctr"/>
-          </a:p>
-        </p:txBody>
-      </p:sp>
-      <p:sp>
-        <p:nvSpPr>
-          <p:cNvPr id="3" name="TextBox 2"/>
+          <p:cNvPr id="2" name="TextBox 1"/>
           <p:cNvSpPr txBox="1"/>
           <p:nvPr/>
         </p:nvSpPr>
@@ -8290,7 +8074,7 @@
       </p:sp>
       <p:sp>
         <p:nvSpPr>
-          <p:cNvPr id="4" name="TextBox 3"/>
+          <p:cNvPr id="3" name="TextBox 2"/>
           <p:cNvSpPr txBox="1"/>
           <p:nvPr/>
         </p:nvSpPr>
@@ -8335,7 +8119,7 @@
       </p:sp>
       <p:sp>
         <p:nvSpPr>
-          <p:cNvPr id="5" name="Rounded Rectangle 4"/>
+          <p:cNvPr id="4" name="Rounded Rectangle 3"/>
           <p:cNvSpPr/>
           <p:nvPr/>
         </p:nvSpPr>
@@ -8381,7 +8165,7 @@
       </p:sp>
       <p:sp>
         <p:nvSpPr>
-          <p:cNvPr id="6" name="TextBox 5"/>
+          <p:cNvPr id="5" name="TextBox 4"/>
           <p:cNvSpPr txBox="1"/>
           <p:nvPr/>
         </p:nvSpPr>
@@ -8470,7 +8254,7 @@
       </p:sp>
       <p:sp>
         <p:nvSpPr>
-          <p:cNvPr id="7" name="Rounded Rectangle 6"/>
+          <p:cNvPr id="6" name="Rounded Rectangle 5"/>
           <p:cNvSpPr/>
           <p:nvPr/>
         </p:nvSpPr>
@@ -8516,7 +8300,7 @@
       </p:sp>
       <p:sp>
         <p:nvSpPr>
-          <p:cNvPr id="8" name="TextBox 7"/>
+          <p:cNvPr id="7" name="TextBox 6"/>
           <p:cNvSpPr txBox="1"/>
           <p:nvPr/>
         </p:nvSpPr>
@@ -8605,7 +8389,7 @@
       </p:sp>
       <p:sp>
         <p:nvSpPr>
-          <p:cNvPr id="9" name="Rounded Rectangle 8"/>
+          <p:cNvPr id="8" name="Rounded Rectangle 7"/>
           <p:cNvSpPr/>
           <p:nvPr/>
         </p:nvSpPr>
@@ -8651,7 +8435,7 @@
       </p:sp>
       <p:sp>
         <p:nvSpPr>
-          <p:cNvPr id="10" name="TextBox 9"/>
+          <p:cNvPr id="9" name="TextBox 8"/>
           <p:cNvSpPr txBox="1"/>
           <p:nvPr/>
         </p:nvSpPr>
@@ -8740,7 +8524,7 @@
       </p:sp>
       <p:sp>
         <p:nvSpPr>
-          <p:cNvPr id="11" name="Rounded Rectangle 10"/>
+          <p:cNvPr id="10" name="Rounded Rectangle 9"/>
           <p:cNvSpPr/>
           <p:nvPr/>
         </p:nvSpPr>
@@ -8788,7 +8572,7 @@
       </p:sp>
       <p:sp>
         <p:nvSpPr>
-          <p:cNvPr id="12" name="TextBox 11"/>
+          <p:cNvPr id="11" name="TextBox 10"/>
           <p:cNvSpPr txBox="1"/>
           <p:nvPr/>
         </p:nvSpPr>
@@ -8833,7 +8617,7 @@
       </p:sp>
       <p:pic>
         <p:nvPicPr>
-          <p:cNvPr id="13" name="Picture 12" descr="logo_trim.png"/>
+          <p:cNvPr id="12" name="Picture 11" descr="logo_trim.png"/>
           <p:cNvPicPr>
             <a:picLocks noChangeAspect="1"/>
           </p:cNvPicPr>
@@ -8857,7 +8641,7 @@
       </p:pic>
       <p:sp>
         <p:nvSpPr>
-          <p:cNvPr id="14" name="TextBox 13"/>
+          <p:cNvPr id="13" name="TextBox 12"/>
           <p:cNvSpPr txBox="1"/>
           <p:nvPr/>
         </p:nvSpPr>
@@ -8902,7 +8686,7 @@
       </p:sp>
       <p:sp>
         <p:nvSpPr>
-          <p:cNvPr id="15" name="TextBox 14"/>
+          <p:cNvPr id="14" name="TextBox 13"/>
           <p:cNvSpPr txBox="1"/>
           <p:nvPr/>
         </p:nvSpPr>
@@ -8956,6 +8740,14 @@
 <file path=ppt/slides/slide5.xml><?xml version="1.0" encoding="utf-8"?>
 <p:sld xmlns:a="http://schemas.openxmlformats.org/drawingml/2006/main" xmlns:p="http://schemas.openxmlformats.org/presentationml/2006/main" xmlns:r="http://schemas.openxmlformats.org/officeDocument/2006/relationships">
   <p:cSld>
+    <p:bg>
+      <p:bgPr>
+        <a:solidFill>
+          <a:srgbClr val="F7F9FB"/>
+        </a:solidFill>
+        <a:effectLst/>
+      </p:bgPr>
+    </p:bg>
     <p:spTree>
       <p:nvGrpSpPr>
         <p:cNvPr id="1" name=""/>
@@ -8965,51 +8757,7 @@
       <p:grpSpPr/>
       <p:sp>
         <p:nvSpPr>
-          <p:cNvPr id="2" name="Rectangle 1"/>
-          <p:cNvSpPr/>
-          <p:nvPr/>
-        </p:nvSpPr>
-        <p:spPr>
-          <a:xfrm>
-            <a:off x="0" y="0"/>
-            <a:ext cx="12191695" cy="6858000"/>
-          </a:xfrm>
-          <a:prstGeom prst="rect">
-            <a:avLst/>
-          </a:prstGeom>
-          <a:solidFill>
-            <a:srgbClr val="F7F9FB"/>
-          </a:solidFill>
-          <a:ln>
-            <a:noFill/>
-          </a:ln>
-          <a:effectLst/>
-        </p:spPr>
-        <p:style>
-          <a:lnRef idx="1">
-            <a:schemeClr val="accent1"/>
-          </a:lnRef>
-          <a:fillRef idx="3">
-            <a:schemeClr val="accent1"/>
-          </a:fillRef>
-          <a:effectRef idx="2">
-            <a:schemeClr val="accent1"/>
-          </a:effectRef>
-          <a:fontRef idx="minor">
-            <a:schemeClr val="lt1"/>
-          </a:fontRef>
-        </p:style>
-        <p:txBody>
-          <a:bodyPr rtlCol="0" anchor="ctr"/>
-          <a:lstStyle/>
-          <a:p>
-            <a:pPr algn="ctr"/>
-          </a:p>
-        </p:txBody>
-      </p:sp>
-      <p:sp>
-        <p:nvSpPr>
-          <p:cNvPr id="3" name="TextBox 2"/>
+          <p:cNvPr id="2" name="TextBox 1"/>
           <p:cNvSpPr txBox="1"/>
           <p:nvPr/>
         </p:nvSpPr>
@@ -9054,7 +8802,7 @@
       </p:sp>
       <p:sp>
         <p:nvSpPr>
-          <p:cNvPr id="4" name="TextBox 3"/>
+          <p:cNvPr id="3" name="TextBox 2"/>
           <p:cNvSpPr txBox="1"/>
           <p:nvPr/>
         </p:nvSpPr>
@@ -9099,7 +8847,7 @@
       </p:sp>
       <p:sp>
         <p:nvSpPr>
-          <p:cNvPr id="5" name="Rounded Rectangle 4"/>
+          <p:cNvPr id="4" name="Rounded Rectangle 3"/>
           <p:cNvSpPr/>
           <p:nvPr/>
         </p:nvSpPr>
@@ -9147,7 +8895,7 @@
       </p:sp>
       <p:sp>
         <p:nvSpPr>
-          <p:cNvPr id="6" name="Rounded Rectangle 5"/>
+          <p:cNvPr id="5" name="Rounded Rectangle 4"/>
           <p:cNvSpPr/>
           <p:nvPr/>
         </p:nvSpPr>
@@ -9193,7 +8941,7 @@
       </p:sp>
       <p:sp>
         <p:nvSpPr>
-          <p:cNvPr id="7" name="TextBox 6"/>
+          <p:cNvPr id="6" name="TextBox 5"/>
           <p:cNvSpPr txBox="1"/>
           <p:nvPr/>
         </p:nvSpPr>
@@ -9238,7 +8986,7 @@
       </p:sp>
       <p:sp>
         <p:nvSpPr>
-          <p:cNvPr id="8" name="TextBox 7"/>
+          <p:cNvPr id="7" name="TextBox 6"/>
           <p:cNvSpPr txBox="1"/>
           <p:nvPr/>
         </p:nvSpPr>
@@ -9283,7 +9031,7 @@
       </p:sp>
       <p:sp>
         <p:nvSpPr>
-          <p:cNvPr id="9" name="TextBox 8"/>
+          <p:cNvPr id="8" name="TextBox 7"/>
           <p:cNvSpPr txBox="1"/>
           <p:nvPr/>
         </p:nvSpPr>
@@ -9328,7 +9076,7 @@
       </p:sp>
       <p:sp>
         <p:nvSpPr>
-          <p:cNvPr id="10" name="Rounded Rectangle 9"/>
+          <p:cNvPr id="9" name="Rounded Rectangle 8"/>
           <p:cNvSpPr/>
           <p:nvPr/>
         </p:nvSpPr>
@@ -9376,7 +9124,7 @@
       </p:sp>
       <p:sp>
         <p:nvSpPr>
-          <p:cNvPr id="11" name="Rounded Rectangle 10"/>
+          <p:cNvPr id="10" name="Rounded Rectangle 9"/>
           <p:cNvSpPr/>
           <p:nvPr/>
         </p:nvSpPr>
@@ -9422,7 +9170,7 @@
       </p:sp>
       <p:sp>
         <p:nvSpPr>
-          <p:cNvPr id="12" name="TextBox 11"/>
+          <p:cNvPr id="11" name="TextBox 10"/>
           <p:cNvSpPr txBox="1"/>
           <p:nvPr/>
         </p:nvSpPr>
@@ -9467,7 +9215,7 @@
       </p:sp>
       <p:sp>
         <p:nvSpPr>
-          <p:cNvPr id="13" name="TextBox 12"/>
+          <p:cNvPr id="12" name="TextBox 11"/>
           <p:cNvSpPr txBox="1"/>
           <p:nvPr/>
         </p:nvSpPr>
@@ -9512,7 +9260,7 @@
       </p:sp>
       <p:sp>
         <p:nvSpPr>
-          <p:cNvPr id="14" name="TextBox 13"/>
+          <p:cNvPr id="13" name="TextBox 12"/>
           <p:cNvSpPr txBox="1"/>
           <p:nvPr/>
         </p:nvSpPr>
@@ -9557,7 +9305,7 @@
       </p:sp>
       <p:sp>
         <p:nvSpPr>
-          <p:cNvPr id="15" name="Rounded Rectangle 14"/>
+          <p:cNvPr id="14" name="Rounded Rectangle 13"/>
           <p:cNvSpPr/>
           <p:nvPr/>
         </p:nvSpPr>
@@ -9605,7 +9353,7 @@
       </p:sp>
       <p:sp>
         <p:nvSpPr>
-          <p:cNvPr id="16" name="Rounded Rectangle 15"/>
+          <p:cNvPr id="15" name="Rounded Rectangle 14"/>
           <p:cNvSpPr/>
           <p:nvPr/>
         </p:nvSpPr>
@@ -9651,7 +9399,7 @@
       </p:sp>
       <p:sp>
         <p:nvSpPr>
-          <p:cNvPr id="17" name="TextBox 16"/>
+          <p:cNvPr id="16" name="TextBox 15"/>
           <p:cNvSpPr txBox="1"/>
           <p:nvPr/>
         </p:nvSpPr>
@@ -9696,7 +9444,7 @@
       </p:sp>
       <p:sp>
         <p:nvSpPr>
-          <p:cNvPr id="18" name="TextBox 17"/>
+          <p:cNvPr id="17" name="TextBox 16"/>
           <p:cNvSpPr txBox="1"/>
           <p:nvPr/>
         </p:nvSpPr>
@@ -9741,7 +9489,7 @@
       </p:sp>
       <p:sp>
         <p:nvSpPr>
-          <p:cNvPr id="19" name="TextBox 18"/>
+          <p:cNvPr id="18" name="TextBox 17"/>
           <p:cNvSpPr txBox="1"/>
           <p:nvPr/>
         </p:nvSpPr>
@@ -9786,7 +9534,7 @@
       </p:sp>
       <p:sp>
         <p:nvSpPr>
-          <p:cNvPr id="20" name="Rounded Rectangle 19"/>
+          <p:cNvPr id="19" name="Rounded Rectangle 18"/>
           <p:cNvSpPr/>
           <p:nvPr/>
         </p:nvSpPr>
@@ -9834,7 +9582,7 @@
       </p:sp>
       <p:sp>
         <p:nvSpPr>
-          <p:cNvPr id="21" name="Rounded Rectangle 20"/>
+          <p:cNvPr id="20" name="Rounded Rectangle 19"/>
           <p:cNvSpPr/>
           <p:nvPr/>
         </p:nvSpPr>
@@ -9880,7 +9628,7 @@
       </p:sp>
       <p:sp>
         <p:nvSpPr>
-          <p:cNvPr id="22" name="TextBox 21"/>
+          <p:cNvPr id="21" name="TextBox 20"/>
           <p:cNvSpPr txBox="1"/>
           <p:nvPr/>
         </p:nvSpPr>
@@ -9925,7 +9673,7 @@
       </p:sp>
       <p:sp>
         <p:nvSpPr>
-          <p:cNvPr id="23" name="TextBox 22"/>
+          <p:cNvPr id="22" name="TextBox 21"/>
           <p:cNvSpPr txBox="1"/>
           <p:nvPr/>
         </p:nvSpPr>
@@ -9970,7 +9718,7 @@
       </p:sp>
       <p:sp>
         <p:nvSpPr>
-          <p:cNvPr id="24" name="TextBox 23"/>
+          <p:cNvPr id="23" name="TextBox 22"/>
           <p:cNvSpPr txBox="1"/>
           <p:nvPr/>
         </p:nvSpPr>
@@ -10015,7 +9763,7 @@
       </p:sp>
       <p:pic>
         <p:nvPicPr>
-          <p:cNvPr id="25" name="Picture 24" descr="logo_trim.png"/>
+          <p:cNvPr id="24" name="Picture 23" descr="logo_trim.png"/>
           <p:cNvPicPr>
             <a:picLocks noChangeAspect="1"/>
           </p:cNvPicPr>
@@ -10039,7 +9787,7 @@
       </p:pic>
       <p:sp>
         <p:nvSpPr>
-          <p:cNvPr id="26" name="TextBox 25"/>
+          <p:cNvPr id="25" name="TextBox 24"/>
           <p:cNvSpPr txBox="1"/>
           <p:nvPr/>
         </p:nvSpPr>
@@ -10084,7 +9832,7 @@
       </p:sp>
       <p:sp>
         <p:nvSpPr>
-          <p:cNvPr id="27" name="TextBox 26"/>
+          <p:cNvPr id="26" name="TextBox 25"/>
           <p:cNvSpPr txBox="1"/>
           <p:nvPr/>
         </p:nvSpPr>
@@ -10138,6 +9886,14 @@
 <file path=ppt/slides/slide6.xml><?xml version="1.0" encoding="utf-8"?>
 <p:sld xmlns:a="http://schemas.openxmlformats.org/drawingml/2006/main" xmlns:p="http://schemas.openxmlformats.org/presentationml/2006/main" xmlns:r="http://schemas.openxmlformats.org/officeDocument/2006/relationships">
   <p:cSld>
+    <p:bg>
+      <p:bgPr>
+        <a:solidFill>
+          <a:srgbClr val="F7F9FB"/>
+        </a:solidFill>
+        <a:effectLst/>
+      </p:bgPr>
+    </p:bg>
     <p:spTree>
       <p:nvGrpSpPr>
         <p:cNvPr id="1" name=""/>
@@ -10147,51 +9903,7 @@
       <p:grpSpPr/>
       <p:sp>
         <p:nvSpPr>
-          <p:cNvPr id="2" name="Rectangle 1"/>
-          <p:cNvSpPr/>
-          <p:nvPr/>
-        </p:nvSpPr>
-        <p:spPr>
-          <a:xfrm>
-            <a:off x="0" y="0"/>
-            <a:ext cx="12191695" cy="6858000"/>
-          </a:xfrm>
-          <a:prstGeom prst="rect">
-            <a:avLst/>
-          </a:prstGeom>
-          <a:solidFill>
-            <a:srgbClr val="F7F9FB"/>
-          </a:solidFill>
-          <a:ln>
-            <a:noFill/>
-          </a:ln>
-          <a:effectLst/>
-        </p:spPr>
-        <p:style>
-          <a:lnRef idx="1">
-            <a:schemeClr val="accent1"/>
-          </a:lnRef>
-          <a:fillRef idx="3">
-            <a:schemeClr val="accent1"/>
-          </a:fillRef>
-          <a:effectRef idx="2">
-            <a:schemeClr val="accent1"/>
-          </a:effectRef>
-          <a:fontRef idx="minor">
-            <a:schemeClr val="lt1"/>
-          </a:fontRef>
-        </p:style>
-        <p:txBody>
-          <a:bodyPr rtlCol="0" anchor="ctr"/>
-          <a:lstStyle/>
-          <a:p>
-            <a:pPr algn="ctr"/>
-          </a:p>
-        </p:txBody>
-      </p:sp>
-      <p:sp>
-        <p:nvSpPr>
-          <p:cNvPr id="3" name="TextBox 2"/>
+          <p:cNvPr id="2" name="TextBox 1"/>
           <p:cNvSpPr txBox="1"/>
           <p:nvPr/>
         </p:nvSpPr>
@@ -10236,7 +9948,7 @@
       </p:sp>
       <p:sp>
         <p:nvSpPr>
-          <p:cNvPr id="4" name="TextBox 3"/>
+          <p:cNvPr id="3" name="TextBox 2"/>
           <p:cNvSpPr txBox="1"/>
           <p:nvPr/>
         </p:nvSpPr>
@@ -10281,7 +9993,7 @@
       </p:sp>
       <p:sp>
         <p:nvSpPr>
-          <p:cNvPr id="5" name="Rounded Rectangle 4"/>
+          <p:cNvPr id="4" name="Rounded Rectangle 3"/>
           <p:cNvSpPr/>
           <p:nvPr/>
         </p:nvSpPr>
@@ -10329,7 +10041,7 @@
       </p:sp>
       <p:sp>
         <p:nvSpPr>
-          <p:cNvPr id="6" name="Rectangle 5"/>
+          <p:cNvPr id="5" name="Rectangle 4"/>
           <p:cNvSpPr/>
           <p:nvPr/>
         </p:nvSpPr>
@@ -10373,7 +10085,7 @@
       </p:sp>
       <p:sp>
         <p:nvSpPr>
-          <p:cNvPr id="7" name="TextBox 6"/>
+          <p:cNvPr id="6" name="TextBox 5"/>
           <p:cNvSpPr txBox="1"/>
           <p:nvPr/>
         </p:nvSpPr>
@@ -10440,7 +10152,7 @@
       </p:sp>
       <p:sp>
         <p:nvSpPr>
-          <p:cNvPr id="8" name="Rounded Rectangle 7"/>
+          <p:cNvPr id="7" name="Rounded Rectangle 6"/>
           <p:cNvSpPr/>
           <p:nvPr/>
         </p:nvSpPr>
@@ -10488,7 +10200,7 @@
       </p:sp>
       <p:sp>
         <p:nvSpPr>
-          <p:cNvPr id="9" name="Rectangle 8"/>
+          <p:cNvPr id="8" name="Rectangle 7"/>
           <p:cNvSpPr/>
           <p:nvPr/>
         </p:nvSpPr>
@@ -10532,7 +10244,7 @@
       </p:sp>
       <p:sp>
         <p:nvSpPr>
-          <p:cNvPr id="10" name="TextBox 9"/>
+          <p:cNvPr id="9" name="TextBox 8"/>
           <p:cNvSpPr txBox="1"/>
           <p:nvPr/>
         </p:nvSpPr>
@@ -10599,7 +10311,7 @@
       </p:sp>
       <p:sp>
         <p:nvSpPr>
-          <p:cNvPr id="11" name="Rounded Rectangle 10"/>
+          <p:cNvPr id="10" name="Rounded Rectangle 9"/>
           <p:cNvSpPr/>
           <p:nvPr/>
         </p:nvSpPr>
@@ -10647,7 +10359,7 @@
       </p:sp>
       <p:sp>
         <p:nvSpPr>
-          <p:cNvPr id="12" name="Rectangle 11"/>
+          <p:cNvPr id="11" name="Rectangle 10"/>
           <p:cNvSpPr/>
           <p:nvPr/>
         </p:nvSpPr>
@@ -10691,7 +10403,7 @@
       </p:sp>
       <p:sp>
         <p:nvSpPr>
-          <p:cNvPr id="13" name="TextBox 12"/>
+          <p:cNvPr id="12" name="TextBox 11"/>
           <p:cNvSpPr txBox="1"/>
           <p:nvPr/>
         </p:nvSpPr>
@@ -10758,7 +10470,7 @@
       </p:sp>
       <p:sp>
         <p:nvSpPr>
-          <p:cNvPr id="14" name="Rounded Rectangle 13"/>
+          <p:cNvPr id="13" name="Rounded Rectangle 12"/>
           <p:cNvSpPr/>
           <p:nvPr/>
         </p:nvSpPr>
@@ -10806,7 +10518,7 @@
       </p:sp>
       <p:sp>
         <p:nvSpPr>
-          <p:cNvPr id="15" name="Rectangle 14"/>
+          <p:cNvPr id="14" name="Rectangle 13"/>
           <p:cNvSpPr/>
           <p:nvPr/>
         </p:nvSpPr>
@@ -10850,7 +10562,7 @@
       </p:sp>
       <p:sp>
         <p:nvSpPr>
-          <p:cNvPr id="16" name="TextBox 15"/>
+          <p:cNvPr id="15" name="TextBox 14"/>
           <p:cNvSpPr txBox="1"/>
           <p:nvPr/>
         </p:nvSpPr>
@@ -10917,7 +10629,7 @@
       </p:sp>
       <p:sp>
         <p:nvSpPr>
-          <p:cNvPr id="17" name="Rounded Rectangle 16"/>
+          <p:cNvPr id="16" name="Rounded Rectangle 15"/>
           <p:cNvSpPr/>
           <p:nvPr/>
         </p:nvSpPr>
@@ -10965,7 +10677,7 @@
       </p:sp>
       <p:sp>
         <p:nvSpPr>
-          <p:cNvPr id="18" name="Rectangle 17"/>
+          <p:cNvPr id="17" name="Rectangle 16"/>
           <p:cNvSpPr/>
           <p:nvPr/>
         </p:nvSpPr>
@@ -11009,7 +10721,7 @@
       </p:sp>
       <p:sp>
         <p:nvSpPr>
-          <p:cNvPr id="19" name="TextBox 18"/>
+          <p:cNvPr id="18" name="TextBox 17"/>
           <p:cNvSpPr txBox="1"/>
           <p:nvPr/>
         </p:nvSpPr>
@@ -11076,7 +10788,7 @@
       </p:sp>
       <p:sp>
         <p:nvSpPr>
-          <p:cNvPr id="20" name="Rounded Rectangle 19"/>
+          <p:cNvPr id="19" name="Rounded Rectangle 18"/>
           <p:cNvSpPr/>
           <p:nvPr/>
         </p:nvSpPr>
@@ -11124,7 +10836,7 @@
       </p:sp>
       <p:sp>
         <p:nvSpPr>
-          <p:cNvPr id="21" name="Rectangle 20"/>
+          <p:cNvPr id="20" name="Rectangle 19"/>
           <p:cNvSpPr/>
           <p:nvPr/>
         </p:nvSpPr>
@@ -11168,7 +10880,7 @@
       </p:sp>
       <p:sp>
         <p:nvSpPr>
-          <p:cNvPr id="22" name="TextBox 21"/>
+          <p:cNvPr id="21" name="TextBox 20"/>
           <p:cNvSpPr txBox="1"/>
           <p:nvPr/>
         </p:nvSpPr>
@@ -11235,7 +10947,7 @@
       </p:sp>
       <p:pic>
         <p:nvPicPr>
-          <p:cNvPr id="23" name="Picture 22" descr="logo_trim.png"/>
+          <p:cNvPr id="22" name="Picture 21" descr="logo_trim.png"/>
           <p:cNvPicPr>
             <a:picLocks noChangeAspect="1"/>
           </p:cNvPicPr>
@@ -11259,7 +10971,7 @@
       </p:pic>
       <p:sp>
         <p:nvSpPr>
-          <p:cNvPr id="24" name="TextBox 23"/>
+          <p:cNvPr id="23" name="TextBox 22"/>
           <p:cNvSpPr txBox="1"/>
           <p:nvPr/>
         </p:nvSpPr>
@@ -11304,7 +11016,7 @@
       </p:sp>
       <p:sp>
         <p:nvSpPr>
-          <p:cNvPr id="25" name="TextBox 24"/>
+          <p:cNvPr id="24" name="TextBox 23"/>
           <p:cNvSpPr txBox="1"/>
           <p:nvPr/>
         </p:nvSpPr>
@@ -11358,6 +11070,14 @@
 <file path=ppt/slides/slide7.xml><?xml version="1.0" encoding="utf-8"?>
 <p:sld xmlns:a="http://schemas.openxmlformats.org/drawingml/2006/main" xmlns:p="http://schemas.openxmlformats.org/presentationml/2006/main" xmlns:r="http://schemas.openxmlformats.org/officeDocument/2006/relationships">
   <p:cSld>
+    <p:bg>
+      <p:bgPr>
+        <a:solidFill>
+          <a:srgbClr val="F7F9FB"/>
+        </a:solidFill>
+        <a:effectLst/>
+      </p:bgPr>
+    </p:bg>
     <p:spTree>
       <p:nvGrpSpPr>
         <p:cNvPr id="1" name=""/>
@@ -11367,51 +11087,7 @@
       <p:grpSpPr/>
       <p:sp>
         <p:nvSpPr>
-          <p:cNvPr id="2" name="Rectangle 1"/>
-          <p:cNvSpPr/>
-          <p:nvPr/>
-        </p:nvSpPr>
-        <p:spPr>
-          <a:xfrm>
-            <a:off x="0" y="0"/>
-            <a:ext cx="12191695" cy="6858000"/>
-          </a:xfrm>
-          <a:prstGeom prst="rect">
-            <a:avLst/>
-          </a:prstGeom>
-          <a:solidFill>
-            <a:srgbClr val="F7F9FB"/>
-          </a:solidFill>
-          <a:ln>
-            <a:noFill/>
-          </a:ln>
-          <a:effectLst/>
-        </p:spPr>
-        <p:style>
-          <a:lnRef idx="1">
-            <a:schemeClr val="accent1"/>
-          </a:lnRef>
-          <a:fillRef idx="3">
-            <a:schemeClr val="accent1"/>
-          </a:fillRef>
-          <a:effectRef idx="2">
-            <a:schemeClr val="accent1"/>
-          </a:effectRef>
-          <a:fontRef idx="minor">
-            <a:schemeClr val="lt1"/>
-          </a:fontRef>
-        </p:style>
-        <p:txBody>
-          <a:bodyPr rtlCol="0" anchor="ctr"/>
-          <a:lstStyle/>
-          <a:p>
-            <a:pPr algn="ctr"/>
-          </a:p>
-        </p:txBody>
-      </p:sp>
-      <p:sp>
-        <p:nvSpPr>
-          <p:cNvPr id="3" name="TextBox 2"/>
+          <p:cNvPr id="2" name="TextBox 1"/>
           <p:cNvSpPr txBox="1"/>
           <p:nvPr/>
         </p:nvSpPr>
@@ -11456,7 +11132,7 @@
       </p:sp>
       <p:sp>
         <p:nvSpPr>
-          <p:cNvPr id="4" name="TextBox 3"/>
+          <p:cNvPr id="3" name="TextBox 2"/>
           <p:cNvSpPr txBox="1"/>
           <p:nvPr/>
         </p:nvSpPr>
@@ -11501,7 +11177,7 @@
       </p:sp>
       <p:sp>
         <p:nvSpPr>
-          <p:cNvPr id="5" name="TextBox 4"/>
+          <p:cNvPr id="4" name="TextBox 3"/>
           <p:cNvSpPr txBox="1"/>
           <p:nvPr/>
         </p:nvSpPr>
@@ -11546,7 +11222,7 @@
       </p:sp>
       <p:sp>
         <p:nvSpPr>
-          <p:cNvPr id="6" name="Rounded Rectangle 5"/>
+          <p:cNvPr id="5" name="Rounded Rectangle 4"/>
           <p:cNvSpPr/>
           <p:nvPr/>
         </p:nvSpPr>
@@ -11594,7 +11270,7 @@
       </p:sp>
       <p:sp>
         <p:nvSpPr>
-          <p:cNvPr id="7" name="Rounded Rectangle 6"/>
+          <p:cNvPr id="6" name="Rounded Rectangle 5"/>
           <p:cNvSpPr/>
           <p:nvPr/>
         </p:nvSpPr>
@@ -11640,7 +11316,7 @@
       </p:sp>
       <p:sp>
         <p:nvSpPr>
-          <p:cNvPr id="8" name="TextBox 7"/>
+          <p:cNvPr id="7" name="TextBox 6"/>
           <p:cNvSpPr txBox="1"/>
           <p:nvPr/>
         </p:nvSpPr>
@@ -11685,7 +11361,7 @@
       </p:sp>
       <p:sp>
         <p:nvSpPr>
-          <p:cNvPr id="9" name="TextBox 8"/>
+          <p:cNvPr id="8" name="TextBox 7"/>
           <p:cNvSpPr txBox="1"/>
           <p:nvPr/>
         </p:nvSpPr>
@@ -11761,7 +11437,7 @@
       </p:sp>
       <p:sp>
         <p:nvSpPr>
-          <p:cNvPr id="10" name="TextBox 9"/>
+          <p:cNvPr id="9" name="TextBox 8"/>
           <p:cNvSpPr txBox="1"/>
           <p:nvPr/>
         </p:nvSpPr>
@@ -11837,7 +11513,7 @@
       </p:sp>
       <p:sp>
         <p:nvSpPr>
-          <p:cNvPr id="11" name="TextBox 10"/>
+          <p:cNvPr id="10" name="TextBox 9"/>
           <p:cNvSpPr txBox="1"/>
           <p:nvPr/>
         </p:nvSpPr>
@@ -11913,7 +11589,7 @@
       </p:sp>
       <p:sp>
         <p:nvSpPr>
-          <p:cNvPr id="12" name="TextBox 11"/>
+          <p:cNvPr id="11" name="TextBox 10"/>
           <p:cNvSpPr txBox="1"/>
           <p:nvPr/>
         </p:nvSpPr>
@@ -11989,7 +11665,7 @@
       </p:sp>
       <p:sp>
         <p:nvSpPr>
-          <p:cNvPr id="13" name="Rounded Rectangle 12"/>
+          <p:cNvPr id="12" name="Rounded Rectangle 11"/>
           <p:cNvSpPr/>
           <p:nvPr/>
         </p:nvSpPr>
@@ -12037,7 +11713,7 @@
       </p:sp>
       <p:sp>
         <p:nvSpPr>
-          <p:cNvPr id="14" name="Rounded Rectangle 13"/>
+          <p:cNvPr id="13" name="Rounded Rectangle 12"/>
           <p:cNvSpPr/>
           <p:nvPr/>
         </p:nvSpPr>
@@ -12083,7 +11759,7 @@
       </p:sp>
       <p:sp>
         <p:nvSpPr>
-          <p:cNvPr id="15" name="TextBox 14"/>
+          <p:cNvPr id="14" name="TextBox 13"/>
           <p:cNvSpPr txBox="1"/>
           <p:nvPr/>
         </p:nvSpPr>
@@ -12128,7 +11804,7 @@
       </p:sp>
       <p:sp>
         <p:nvSpPr>
-          <p:cNvPr id="16" name="TextBox 15"/>
+          <p:cNvPr id="15" name="TextBox 14"/>
           <p:cNvSpPr txBox="1"/>
           <p:nvPr/>
         </p:nvSpPr>
@@ -12204,7 +11880,7 @@
       </p:sp>
       <p:sp>
         <p:nvSpPr>
-          <p:cNvPr id="17" name="TextBox 16"/>
+          <p:cNvPr id="16" name="TextBox 15"/>
           <p:cNvSpPr txBox="1"/>
           <p:nvPr/>
         </p:nvSpPr>
@@ -12280,7 +11956,7 @@
       </p:sp>
       <p:sp>
         <p:nvSpPr>
-          <p:cNvPr id="18" name="TextBox 17"/>
+          <p:cNvPr id="17" name="TextBox 16"/>
           <p:cNvSpPr txBox="1"/>
           <p:nvPr/>
         </p:nvSpPr>
@@ -12356,7 +12032,7 @@
       </p:sp>
       <p:sp>
         <p:nvSpPr>
-          <p:cNvPr id="19" name="TextBox 18"/>
+          <p:cNvPr id="18" name="TextBox 17"/>
           <p:cNvSpPr txBox="1"/>
           <p:nvPr/>
         </p:nvSpPr>
@@ -12432,7 +12108,7 @@
       </p:sp>
       <p:sp>
         <p:nvSpPr>
-          <p:cNvPr id="20" name="Rounded Rectangle 19"/>
+          <p:cNvPr id="19" name="Rounded Rectangle 18"/>
           <p:cNvSpPr/>
           <p:nvPr/>
         </p:nvSpPr>
@@ -12480,7 +12156,7 @@
       </p:sp>
       <p:sp>
         <p:nvSpPr>
-          <p:cNvPr id="21" name="Rounded Rectangle 20"/>
+          <p:cNvPr id="20" name="Rounded Rectangle 19"/>
           <p:cNvSpPr/>
           <p:nvPr/>
         </p:nvSpPr>
@@ -12526,7 +12202,7 @@
       </p:sp>
       <p:sp>
         <p:nvSpPr>
-          <p:cNvPr id="22" name="TextBox 21"/>
+          <p:cNvPr id="21" name="TextBox 20"/>
           <p:cNvSpPr txBox="1"/>
           <p:nvPr/>
         </p:nvSpPr>
@@ -12571,7 +12247,7 @@
       </p:sp>
       <p:sp>
         <p:nvSpPr>
-          <p:cNvPr id="23" name="TextBox 22"/>
+          <p:cNvPr id="22" name="TextBox 21"/>
           <p:cNvSpPr txBox="1"/>
           <p:nvPr/>
         </p:nvSpPr>
@@ -12647,7 +12323,7 @@
       </p:sp>
       <p:sp>
         <p:nvSpPr>
-          <p:cNvPr id="24" name="TextBox 23"/>
+          <p:cNvPr id="23" name="TextBox 22"/>
           <p:cNvSpPr txBox="1"/>
           <p:nvPr/>
         </p:nvSpPr>
@@ -12723,7 +12399,7 @@
       </p:sp>
       <p:sp>
         <p:nvSpPr>
-          <p:cNvPr id="25" name="TextBox 24"/>
+          <p:cNvPr id="24" name="TextBox 23"/>
           <p:cNvSpPr txBox="1"/>
           <p:nvPr/>
         </p:nvSpPr>
@@ -12799,7 +12475,7 @@
       </p:sp>
       <p:sp>
         <p:nvSpPr>
-          <p:cNvPr id="26" name="TextBox 25"/>
+          <p:cNvPr id="25" name="TextBox 24"/>
           <p:cNvSpPr txBox="1"/>
           <p:nvPr/>
         </p:nvSpPr>
@@ -12875,7 +12551,7 @@
       </p:sp>
       <p:pic>
         <p:nvPicPr>
-          <p:cNvPr id="27" name="Picture 26" descr="logo_trim.png"/>
+          <p:cNvPr id="26" name="Picture 25" descr="logo_trim.png"/>
           <p:cNvPicPr>
             <a:picLocks noChangeAspect="1"/>
           </p:cNvPicPr>
@@ -12899,7 +12575,7 @@
       </p:pic>
       <p:sp>
         <p:nvSpPr>
-          <p:cNvPr id="28" name="TextBox 27"/>
+          <p:cNvPr id="27" name="TextBox 26"/>
           <p:cNvSpPr txBox="1"/>
           <p:nvPr/>
         </p:nvSpPr>
@@ -12944,7 +12620,7 @@
       </p:sp>
       <p:sp>
         <p:nvSpPr>
-          <p:cNvPr id="29" name="TextBox 28"/>
+          <p:cNvPr id="28" name="TextBox 27"/>
           <p:cNvSpPr txBox="1"/>
           <p:nvPr/>
         </p:nvSpPr>
@@ -12998,6 +12674,14 @@
 <file path=ppt/slides/slide8.xml><?xml version="1.0" encoding="utf-8"?>
 <p:sld xmlns:a="http://schemas.openxmlformats.org/drawingml/2006/main" xmlns:p="http://schemas.openxmlformats.org/presentationml/2006/main" xmlns:r="http://schemas.openxmlformats.org/officeDocument/2006/relationships">
   <p:cSld>
+    <p:bg>
+      <p:bgPr>
+        <a:solidFill>
+          <a:srgbClr val="F7F9FB"/>
+        </a:solidFill>
+        <a:effectLst/>
+      </p:bgPr>
+    </p:bg>
     <p:spTree>
       <p:nvGrpSpPr>
         <p:cNvPr id="1" name=""/>
@@ -13007,51 +12691,7 @@
       <p:grpSpPr/>
       <p:sp>
         <p:nvSpPr>
-          <p:cNvPr id="2" name="Rectangle 1"/>
-          <p:cNvSpPr/>
-          <p:nvPr/>
-        </p:nvSpPr>
-        <p:spPr>
-          <a:xfrm>
-            <a:off x="0" y="0"/>
-            <a:ext cx="12191695" cy="6858000"/>
-          </a:xfrm>
-          <a:prstGeom prst="rect">
-            <a:avLst/>
-          </a:prstGeom>
-          <a:solidFill>
-            <a:srgbClr val="F7F9FB"/>
-          </a:solidFill>
-          <a:ln>
-            <a:noFill/>
-          </a:ln>
-          <a:effectLst/>
-        </p:spPr>
-        <p:style>
-          <a:lnRef idx="1">
-            <a:schemeClr val="accent1"/>
-          </a:lnRef>
-          <a:fillRef idx="3">
-            <a:schemeClr val="accent1"/>
-          </a:fillRef>
-          <a:effectRef idx="2">
-            <a:schemeClr val="accent1"/>
-          </a:effectRef>
-          <a:fontRef idx="minor">
-            <a:schemeClr val="lt1"/>
-          </a:fontRef>
-        </p:style>
-        <p:txBody>
-          <a:bodyPr rtlCol="0" anchor="ctr"/>
-          <a:lstStyle/>
-          <a:p>
-            <a:pPr algn="ctr"/>
-          </a:p>
-        </p:txBody>
-      </p:sp>
-      <p:sp>
-        <p:nvSpPr>
-          <p:cNvPr id="3" name="TextBox 2"/>
+          <p:cNvPr id="2" name="TextBox 1"/>
           <p:cNvSpPr txBox="1"/>
           <p:nvPr/>
         </p:nvSpPr>
@@ -13096,7 +12736,7 @@
       </p:sp>
       <p:sp>
         <p:nvSpPr>
-          <p:cNvPr id="4" name="TextBox 3"/>
+          <p:cNvPr id="3" name="TextBox 2"/>
           <p:cNvSpPr txBox="1"/>
           <p:nvPr/>
         </p:nvSpPr>
@@ -13141,7 +12781,7 @@
       </p:sp>
       <p:sp>
         <p:nvSpPr>
-          <p:cNvPr id="5" name="Rounded Rectangle 4"/>
+          <p:cNvPr id="4" name="Rounded Rectangle 3"/>
           <p:cNvSpPr/>
           <p:nvPr/>
         </p:nvSpPr>
@@ -13187,7 +12827,7 @@
       </p:sp>
       <p:sp>
         <p:nvSpPr>
-          <p:cNvPr id="6" name="TextBox 5"/>
+          <p:cNvPr id="5" name="TextBox 4"/>
           <p:cNvSpPr txBox="1"/>
           <p:nvPr/>
         </p:nvSpPr>
@@ -13254,7 +12894,7 @@
       </p:sp>
       <p:sp>
         <p:nvSpPr>
-          <p:cNvPr id="7" name="Rounded Rectangle 6"/>
+          <p:cNvPr id="6" name="Rounded Rectangle 5"/>
           <p:cNvSpPr/>
           <p:nvPr/>
         </p:nvSpPr>
@@ -13300,7 +12940,7 @@
       </p:sp>
       <p:sp>
         <p:nvSpPr>
-          <p:cNvPr id="8" name="TextBox 7"/>
+          <p:cNvPr id="7" name="TextBox 6"/>
           <p:cNvSpPr txBox="1"/>
           <p:nvPr/>
         </p:nvSpPr>
@@ -13345,7 +12985,7 @@
       </p:sp>
       <p:sp>
         <p:nvSpPr>
-          <p:cNvPr id="9" name="TextBox 8"/>
+          <p:cNvPr id="8" name="TextBox 7"/>
           <p:cNvSpPr txBox="1"/>
           <p:nvPr/>
         </p:nvSpPr>
@@ -13456,7 +13096,7 @@
       </p:sp>
       <p:sp>
         <p:nvSpPr>
-          <p:cNvPr id="10" name="Right Arrow 9"/>
+          <p:cNvPr id="9" name="Right Arrow 8"/>
           <p:cNvSpPr/>
           <p:nvPr/>
         </p:nvSpPr>
@@ -13500,7 +13140,7 @@
       </p:sp>
       <p:sp>
         <p:nvSpPr>
-          <p:cNvPr id="11" name="Rounded Rectangle 10"/>
+          <p:cNvPr id="10" name="Rounded Rectangle 9"/>
           <p:cNvSpPr/>
           <p:nvPr/>
         </p:nvSpPr>
@@ -13546,7 +13186,7 @@
       </p:sp>
       <p:sp>
         <p:nvSpPr>
-          <p:cNvPr id="12" name="TextBox 11"/>
+          <p:cNvPr id="11" name="TextBox 10"/>
           <p:cNvSpPr txBox="1"/>
           <p:nvPr/>
         </p:nvSpPr>
@@ -13613,7 +13253,7 @@
       </p:sp>
       <p:sp>
         <p:nvSpPr>
-          <p:cNvPr id="13" name="Rounded Rectangle 12"/>
+          <p:cNvPr id="12" name="Rounded Rectangle 11"/>
           <p:cNvSpPr/>
           <p:nvPr/>
         </p:nvSpPr>
@@ -13659,7 +13299,7 @@
       </p:sp>
       <p:sp>
         <p:nvSpPr>
-          <p:cNvPr id="14" name="TextBox 13"/>
+          <p:cNvPr id="13" name="TextBox 12"/>
           <p:cNvSpPr txBox="1"/>
           <p:nvPr/>
         </p:nvSpPr>
@@ -13704,7 +13344,7 @@
       </p:sp>
       <p:sp>
         <p:nvSpPr>
-          <p:cNvPr id="15" name="TextBox 14"/>
+          <p:cNvPr id="14" name="TextBox 13"/>
           <p:cNvSpPr txBox="1"/>
           <p:nvPr/>
         </p:nvSpPr>
@@ -13815,7 +13455,7 @@
       </p:sp>
       <p:sp>
         <p:nvSpPr>
-          <p:cNvPr id="16" name="Right Arrow 15"/>
+          <p:cNvPr id="15" name="Right Arrow 14"/>
           <p:cNvSpPr/>
           <p:nvPr/>
         </p:nvSpPr>
@@ -13859,7 +13499,7 @@
       </p:sp>
       <p:sp>
         <p:nvSpPr>
-          <p:cNvPr id="17" name="Rounded Rectangle 16"/>
+          <p:cNvPr id="16" name="Rounded Rectangle 15"/>
           <p:cNvSpPr/>
           <p:nvPr/>
         </p:nvSpPr>
@@ -13905,7 +13545,7 @@
       </p:sp>
       <p:sp>
         <p:nvSpPr>
-          <p:cNvPr id="18" name="TextBox 17"/>
+          <p:cNvPr id="17" name="TextBox 16"/>
           <p:cNvSpPr txBox="1"/>
           <p:nvPr/>
         </p:nvSpPr>
@@ -13972,7 +13612,7 @@
       </p:sp>
       <p:sp>
         <p:nvSpPr>
-          <p:cNvPr id="19" name="Rounded Rectangle 18"/>
+          <p:cNvPr id="18" name="Rounded Rectangle 17"/>
           <p:cNvSpPr/>
           <p:nvPr/>
         </p:nvSpPr>
@@ -14018,7 +13658,7 @@
       </p:sp>
       <p:sp>
         <p:nvSpPr>
-          <p:cNvPr id="20" name="TextBox 19"/>
+          <p:cNvPr id="19" name="TextBox 18"/>
           <p:cNvSpPr txBox="1"/>
           <p:nvPr/>
         </p:nvSpPr>
@@ -14063,7 +13703,7 @@
       </p:sp>
       <p:sp>
         <p:nvSpPr>
-          <p:cNvPr id="21" name="TextBox 20"/>
+          <p:cNvPr id="20" name="TextBox 19"/>
           <p:cNvSpPr txBox="1"/>
           <p:nvPr/>
         </p:nvSpPr>
@@ -14174,7 +13814,7 @@
       </p:sp>
       <p:pic>
         <p:nvPicPr>
-          <p:cNvPr id="22" name="Picture 21" descr="logo_trim.png"/>
+          <p:cNvPr id="21" name="Picture 20" descr="logo_trim.png"/>
           <p:cNvPicPr>
             <a:picLocks noChangeAspect="1"/>
           </p:cNvPicPr>
@@ -14198,7 +13838,7 @@
       </p:pic>
       <p:sp>
         <p:nvSpPr>
-          <p:cNvPr id="23" name="TextBox 22"/>
+          <p:cNvPr id="22" name="TextBox 21"/>
           <p:cNvSpPr txBox="1"/>
           <p:nvPr/>
         </p:nvSpPr>
@@ -14243,7 +13883,7 @@
       </p:sp>
       <p:sp>
         <p:nvSpPr>
-          <p:cNvPr id="24" name="TextBox 23"/>
+          <p:cNvPr id="23" name="TextBox 22"/>
           <p:cNvSpPr txBox="1"/>
           <p:nvPr/>
         </p:nvSpPr>
@@ -14297,6 +13937,14 @@
 <file path=ppt/slides/slide9.xml><?xml version="1.0" encoding="utf-8"?>
 <p:sld xmlns:a="http://schemas.openxmlformats.org/drawingml/2006/main" xmlns:p="http://schemas.openxmlformats.org/presentationml/2006/main" xmlns:r="http://schemas.openxmlformats.org/officeDocument/2006/relationships">
   <p:cSld>
+    <p:bg>
+      <p:bgPr>
+        <a:solidFill>
+          <a:srgbClr val="F7F9FB"/>
+        </a:solidFill>
+        <a:effectLst/>
+      </p:bgPr>
+    </p:bg>
     <p:spTree>
       <p:nvGrpSpPr>
         <p:cNvPr id="1" name=""/>
@@ -14306,51 +13954,7 @@
       <p:grpSpPr/>
       <p:sp>
         <p:nvSpPr>
-          <p:cNvPr id="2" name="Rectangle 1"/>
-          <p:cNvSpPr/>
-          <p:nvPr/>
-        </p:nvSpPr>
-        <p:spPr>
-          <a:xfrm>
-            <a:off x="0" y="0"/>
-            <a:ext cx="12191695" cy="6858000"/>
-          </a:xfrm>
-          <a:prstGeom prst="rect">
-            <a:avLst/>
-          </a:prstGeom>
-          <a:solidFill>
-            <a:srgbClr val="F7F9FB"/>
-          </a:solidFill>
-          <a:ln>
-            <a:noFill/>
-          </a:ln>
-          <a:effectLst/>
-        </p:spPr>
-        <p:style>
-          <a:lnRef idx="1">
-            <a:schemeClr val="accent1"/>
-          </a:lnRef>
-          <a:fillRef idx="3">
-            <a:schemeClr val="accent1"/>
-          </a:fillRef>
-          <a:effectRef idx="2">
-            <a:schemeClr val="accent1"/>
-          </a:effectRef>
-          <a:fontRef idx="minor">
-            <a:schemeClr val="lt1"/>
-          </a:fontRef>
-        </p:style>
-        <p:txBody>
-          <a:bodyPr rtlCol="0" anchor="ctr"/>
-          <a:lstStyle/>
-          <a:p>
-            <a:pPr algn="ctr"/>
-          </a:p>
-        </p:txBody>
-      </p:sp>
-      <p:sp>
-        <p:nvSpPr>
-          <p:cNvPr id="3" name="TextBox 2"/>
+          <p:cNvPr id="2" name="TextBox 1"/>
           <p:cNvSpPr txBox="1"/>
           <p:nvPr/>
         </p:nvSpPr>
@@ -14395,7 +13999,7 @@
       </p:sp>
       <p:sp>
         <p:nvSpPr>
-          <p:cNvPr id="4" name="TextBox 3"/>
+          <p:cNvPr id="3" name="TextBox 2"/>
           <p:cNvSpPr txBox="1"/>
           <p:nvPr/>
         </p:nvSpPr>
@@ -14440,7 +14044,7 @@
       </p:sp>
       <p:sp>
         <p:nvSpPr>
-          <p:cNvPr id="5" name="TextBox 4"/>
+          <p:cNvPr id="4" name="TextBox 3"/>
           <p:cNvSpPr txBox="1"/>
           <p:nvPr/>
         </p:nvSpPr>
@@ -14485,7 +14089,7 @@
       </p:sp>
       <p:sp>
         <p:nvSpPr>
-          <p:cNvPr id="6" name="Rounded Rectangle 5"/>
+          <p:cNvPr id="5" name="Rounded Rectangle 4"/>
           <p:cNvSpPr/>
           <p:nvPr/>
         </p:nvSpPr>
@@ -14533,7 +14137,7 @@
       </p:sp>
       <p:sp>
         <p:nvSpPr>
-          <p:cNvPr id="7" name="TextBox 6"/>
+          <p:cNvPr id="6" name="TextBox 5"/>
           <p:cNvSpPr txBox="1"/>
           <p:nvPr/>
         </p:nvSpPr>
@@ -14644,7 +14248,7 @@
       </p:sp>
       <p:sp>
         <p:nvSpPr>
-          <p:cNvPr id="8" name="Rounded Rectangle 7"/>
+          <p:cNvPr id="7" name="Rounded Rectangle 6"/>
           <p:cNvSpPr/>
           <p:nvPr/>
         </p:nvSpPr>
@@ -14692,7 +14296,7 @@
       </p:sp>
       <p:sp>
         <p:nvSpPr>
-          <p:cNvPr id="9" name="Rounded Rectangle 8"/>
+          <p:cNvPr id="8" name="Rounded Rectangle 7"/>
           <p:cNvSpPr/>
           <p:nvPr/>
         </p:nvSpPr>
@@ -14738,7 +14342,7 @@
       </p:sp>
       <p:sp>
         <p:nvSpPr>
-          <p:cNvPr id="10" name="TextBox 9"/>
+          <p:cNvPr id="9" name="TextBox 8"/>
           <p:cNvSpPr txBox="1"/>
           <p:nvPr/>
         </p:nvSpPr>
@@ -14783,7 +14387,7 @@
       </p:sp>
       <p:sp>
         <p:nvSpPr>
-          <p:cNvPr id="11" name="TextBox 10"/>
+          <p:cNvPr id="10" name="TextBox 9"/>
           <p:cNvSpPr txBox="1"/>
           <p:nvPr/>
         </p:nvSpPr>
@@ -14894,7 +14498,7 @@
       </p:sp>
       <p:sp>
         <p:nvSpPr>
-          <p:cNvPr id="12" name="Rounded Rectangle 11"/>
+          <p:cNvPr id="11" name="Rounded Rectangle 10"/>
           <p:cNvSpPr/>
           <p:nvPr/>
         </p:nvSpPr>
@@ -14942,7 +14546,7 @@
       </p:sp>
       <p:sp>
         <p:nvSpPr>
-          <p:cNvPr id="13" name="TextBox 12"/>
+          <p:cNvPr id="12" name="TextBox 11"/>
           <p:cNvSpPr txBox="1"/>
           <p:nvPr/>
         </p:nvSpPr>
@@ -15053,7 +14657,7 @@
       </p:sp>
       <p:sp>
         <p:nvSpPr>
-          <p:cNvPr id="14" name="TextBox 13"/>
+          <p:cNvPr id="13" name="TextBox 12"/>
           <p:cNvSpPr txBox="1"/>
           <p:nvPr/>
         </p:nvSpPr>
@@ -15098,7 +14702,7 @@
       </p:sp>
       <p:pic>
         <p:nvPicPr>
-          <p:cNvPr id="15" name="Picture 14" descr="logo_trim.png"/>
+          <p:cNvPr id="14" name="Picture 13" descr="logo_trim.png"/>
           <p:cNvPicPr>
             <a:picLocks noChangeAspect="1"/>
           </p:cNvPicPr>
@@ -15122,7 +14726,7 @@
       </p:pic>
       <p:sp>
         <p:nvSpPr>
-          <p:cNvPr id="16" name="TextBox 15"/>
+          <p:cNvPr id="15" name="TextBox 14"/>
           <p:cNvSpPr txBox="1"/>
           <p:nvPr/>
         </p:nvSpPr>
@@ -15167,7 +14771,7 @@
       </p:sp>
       <p:sp>
         <p:nvSpPr>
-          <p:cNvPr id="17" name="TextBox 16"/>
+          <p:cNvPr id="16" name="TextBox 15"/>
           <p:cNvSpPr txBox="1"/>
           <p:nvPr/>
         </p:nvSpPr>

</xml_diff>

<commit_message>
fix(pitch): correct oversized gold bar on cover/close (blanked Google Slides edit)
The cover and closing slides drew the gold top bar with rect(s,0,0,SW,0.14),
passing SW (prs.slide_width, already in EMU) into a helper that re-wraps args
in Inches() — producing a bar ~12 MILLION inches wide. PowerPoint, thumbnails,
and Slideshow clip it, but the Google Slides EDIT canvas can't lay out a shape
that large and renders the slide blank. Pass inches (13.333) instead. All shapes
now within slide bounds; this was the real cause of the blank first slide.

Co-Authored-By: Claude Opus 4.8 <noreply@anthropic.com>
Claude-Session: https://claude.ai/code/session_01EiquWdpoHJaLq9xBqbbKr9
</commit_message>
<xml_diff>
--- a/docs/pitch-deck-v3.pptx
+++ b/docs/pitch-deck-v3.pptx
@@ -4235,7 +4235,7 @@
         <p:spPr>
           <a:xfrm>
             <a:off x="0" y="0"/>
-            <a:ext cx="11148085908000" cy="128016"/>
+            <a:ext cx="12191695" cy="128016"/>
           </a:xfrm>
           <a:prstGeom prst="rect">
             <a:avLst/>
@@ -5711,7 +5711,7 @@
         <p:spPr>
           <a:xfrm>
             <a:off x="0" y="0"/>
-            <a:ext cx="11148085908000" cy="128016"/>
+            <a:ext cx="12191695" cy="128016"/>
           </a:xfrm>
           <a:prstGeom prst="rect">
             <a:avLst/>

</xml_diff>